<commit_message>
docs: add a NAT behavior slide to the deck
Adds a short slide naming the mapping behaviors, an example of each, and
what each does to hole punching: endpoint-independent on most home
routers, where punching works; address-dependent on some enterprise NATs,
where both sides must punch; address-and-port-dependent on many mobile
carriers, where punching fails without port prediction; and carrier-grade
NAT stacked above all of it, which admits no unsolicited inbound at all.

The measurand slide is absorbed into it, since the tuple is these
behaviors, and its two remaining points — that autoNAT reports
reachability only and that classification is validated against the RFC
5780 server — move to the validation slide, where the ground truth is
already the subject. The deck stays at ten slides.

Co-Authored-By: claude-flow <ruv@ruv.net>
</commit_message>
<xml_diff>
--- a/docs/student-projects/grassroots-nat-project.pptx
+++ b/docs/student-projects/grassroots-nat-project.pptx
@@ -775,7 +775,7 @@
           <a:p>
             <a:r>
               <a:rPr lang="en-US" dirty="0"/>
-              <a:t>Confirmed in source at grassroots_network.dart:3369. This is the clearest motivation for the project: the system cannot distinguish a public address from a reachable one, and every consequence follows from that.</a:t>
+              <a:t>Filtering is the second axis: which inbound traffic is admitted on an existing mapping, endpoint-independent through address-and-port-dependent. Mapping decides whether a port can be predicted at all; filtering decides whether the arriving packet is let through. Port preservation is why the current code sometimes works by accident, and mapping lifetime sets the keepalive interval.</a:t>
             </a:r>
             <a:endParaRPr lang="en-US" dirty="0"/>
           </a:p>
@@ -863,7 +863,7 @@
           <a:p>
             <a:r>
               <a:rPr lang="en-US" dirty="0"/>
-              <a:t>Reflections from friends at distinct addresses give mapping behavior. Filtering follows from where the dial-backs come from, classified against our own send history: a friend we have a session with, the same friend on a fresh source port, and a friend we have never transmitted to. No friend is ever asked to dial anyone but us, so there is no amplification vector and no relaying for non-friends, which the signaling design forbids anyway.</a:t>
+              <a:t>Confirmed in source at grassroots_network.dart:3369. This is the clearest motivation for the project: the system cannot distinguish a public address from a reachable one, and every consequence follows from that.</a:t>
             </a:r>
             <a:endParaRPr lang="en-US" dirty="0"/>
           </a:p>
@@ -951,7 +951,7 @@
           <a:p>
             <a:r>
               <a:rPr lang="en-US" dirty="0"/>
-              <a:t>Contamination is the one that would quietly invalidate a field campaign: it biases in the direction that looks like good news. We publish the label difference between contaminated and clean runs as a result in its own right. The aggregation asymmetry follows from the nonce being unforgeable while a claimed failure is free.</a:t>
+              <a:t>Reflections from friends at distinct addresses give mapping behavior. Filtering follows from where the dial-backs come from, classified against our own send history: a friend we have a session with, the same friend on a fresh source port, and a friend we have never transmitted to. No friend is ever asked to dial anyone but us, so there is no amplification vector and no relaying for non-friends, which the signaling design forbids anyway.</a:t>
             </a:r>
             <a:endParaRPr lang="en-US" dirty="0"/>
           </a:p>
@@ -1039,7 +1039,7 @@
           <a:p>
             <a:r>
               <a:rPr lang="en-US" dirty="0"/>
-              <a:t>On a 464XLAT path the thing characterized is the carrier translator, which RFC 4787 describes only partially; on native IPv6 there is no mapping at all and only filtering, so mapping and port preservation are N/A rather than absent. CGNAT status and IPv6 availability are recorded alongside.</a:t>
+              <a:t>Contamination is the one that would quietly invalidate a field campaign: it biases in the direction that looks like good news. We publish the label difference between contaminated and clean runs as a result in its own right. The aggregation asymmetry follows from the nonce being unforgeable while a claimed failure is free.</a:t>
             </a:r>
             <a:endParaRPr lang="en-US" dirty="0"/>
           </a:p>
@@ -3412,6 +3412,787 @@
 <file path=ppt/slides/slide3.xml><?xml version="1.0" encoding="utf-8"?>
 <p:sld xmlns:a="http://schemas.openxmlformats.org/drawingml/2006/main" xmlns:r="http://schemas.openxmlformats.org/officeDocument/2006/relationships" xmlns:p="http://schemas.openxmlformats.org/presentationml/2006/main">
   <p:cSld name="Slide 3">
+    <p:spTree>
+      <p:nvGrpSpPr>
+        <p:cNvPr id="1" name=""/>
+        <p:cNvGrpSpPr/>
+        <p:nvPr/>
+      </p:nvGrpSpPr>
+      <p:grpSpPr>
+        <a:xfrm>
+          <a:off x="0" y="0"/>
+          <a:ext cx="0" cy="0"/>
+          <a:chOff x="0" y="0"/>
+          <a:chExt cx="0" cy="0"/>
+        </a:xfrm>
+      </p:grpSpPr>
+      <p:sp>
+        <p:nvSpPr>
+          <p:cNvPr id="2" name="Text 0"/>
+          <p:cNvSpPr/>
+          <p:nvPr/>
+        </p:nvSpPr>
+        <p:spPr>
+          <a:xfrm>
+            <a:off x="685800" y="502920"/>
+            <a:ext cx="10789920" cy="274320"/>
+          </a:xfrm>
+          <a:prstGeom prst="rect">
+            <a:avLst/>
+          </a:prstGeom>
+          <a:noFill/>
+          <a:ln/>
+        </p:spPr>
+        <p:txBody>
+          <a:bodyPr wrap="square" lIns="0" tIns="0" rIns="0" bIns="0" rtlCol="0" anchor="ctr"/>
+          <a:lstStyle/>
+          <a:p>
+            <a:pPr indent="0" marL="0">
+              <a:buNone/>
+            </a:pPr>
+            <a:r>
+              <a:rPr lang="en-US" sz="1100" b="1" spc="200" kern="0" dirty="0">
+                <a:solidFill>
+                  <a:srgbClr val="0E7C86"/>
+                </a:solidFill>
+                <a:latin typeface="Calibri" pitchFamily="34" charset="0"/>
+                <a:ea typeface="Calibri" pitchFamily="34" charset="-122"/>
+                <a:cs typeface="Calibri" pitchFamily="34" charset="-120"/>
+              </a:rPr>
+              <a:t>WHAT WE MUST DISTINGUISH</a:t>
+            </a:r>
+            <a:endParaRPr lang="en-US" sz="1100" dirty="0"/>
+          </a:p>
+        </p:txBody>
+      </p:sp>
+      <p:sp>
+        <p:nvSpPr>
+          <p:cNvPr id="3" name="Text 1"/>
+          <p:cNvSpPr/>
+          <p:nvPr/>
+        </p:nvSpPr>
+        <p:spPr>
+          <a:xfrm>
+            <a:off x="685800" y="804672"/>
+            <a:ext cx="10789920" cy="822960"/>
+          </a:xfrm>
+          <a:prstGeom prst="rect">
+            <a:avLst/>
+          </a:prstGeom>
+          <a:noFill/>
+          <a:ln/>
+        </p:spPr>
+        <p:txBody>
+          <a:bodyPr wrap="square" lIns="0" tIns="0" rIns="0" bIns="0" rtlCol="0" anchor="ctr"/>
+          <a:lstStyle/>
+          <a:p>
+            <a:pPr indent="0" marL="0">
+              <a:buNone/>
+            </a:pPr>
+            <a:r>
+              <a:rPr lang="en-US" sz="3600" b="1" dirty="0">
+                <a:solidFill>
+                  <a:srgbClr val="16202A"/>
+                </a:solidFill>
+                <a:latin typeface="Cambria" pitchFamily="34" charset="0"/>
+                <a:ea typeface="Cambria" pitchFamily="34" charset="-122"/>
+                <a:cs typeface="Cambria" pitchFamily="34" charset="-120"/>
+              </a:rPr>
+              <a:t>NAT behavior</a:t>
+            </a:r>
+            <a:endParaRPr lang="en-US" sz="3600" dirty="0"/>
+          </a:p>
+        </p:txBody>
+      </p:sp>
+      <p:sp>
+        <p:nvSpPr>
+          <p:cNvPr id="4" name="Text 2"/>
+          <p:cNvSpPr/>
+          <p:nvPr/>
+        </p:nvSpPr>
+        <p:spPr>
+          <a:xfrm>
+            <a:off x="685800" y="1965960"/>
+            <a:ext cx="3474720" cy="274320"/>
+          </a:xfrm>
+          <a:prstGeom prst="rect">
+            <a:avLst/>
+          </a:prstGeom>
+          <a:noFill/>
+          <a:ln/>
+        </p:spPr>
+        <p:txBody>
+          <a:bodyPr wrap="square" lIns="0" tIns="0" rIns="0" bIns="0" rtlCol="0" anchor="ctr"/>
+          <a:lstStyle/>
+          <a:p>
+            <a:pPr indent="0" marL="0">
+              <a:buNone/>
+            </a:pPr>
+            <a:r>
+              <a:rPr lang="en-US" sz="1000" b="1" spc="150" kern="0" dirty="0">
+                <a:solidFill>
+                  <a:srgbClr val="6E7F8B"/>
+                </a:solidFill>
+                <a:latin typeface="Calibri" pitchFamily="34" charset="0"/>
+                <a:ea typeface="Calibri" pitchFamily="34" charset="-122"/>
+                <a:cs typeface="Calibri" pitchFamily="34" charset="-120"/>
+              </a:rPr>
+              <a:t>BEHAVIOR</a:t>
+            </a:r>
+            <a:endParaRPr lang="en-US" sz="1000" dirty="0"/>
+          </a:p>
+        </p:txBody>
+      </p:sp>
+      <p:sp>
+        <p:nvSpPr>
+          <p:cNvPr id="5" name="Text 3"/>
+          <p:cNvSpPr/>
+          <p:nvPr/>
+        </p:nvSpPr>
+        <p:spPr>
+          <a:xfrm>
+            <a:off x="4343400" y="1965960"/>
+            <a:ext cx="2468880" cy="274320"/>
+          </a:xfrm>
+          <a:prstGeom prst="rect">
+            <a:avLst/>
+          </a:prstGeom>
+          <a:noFill/>
+          <a:ln/>
+        </p:spPr>
+        <p:txBody>
+          <a:bodyPr wrap="square" lIns="0" tIns="0" rIns="0" bIns="0" rtlCol="0" anchor="ctr"/>
+          <a:lstStyle/>
+          <a:p>
+            <a:pPr indent="0" marL="0">
+              <a:buNone/>
+            </a:pPr>
+            <a:r>
+              <a:rPr lang="en-US" sz="1000" b="1" spc="150" kern="0" dirty="0">
+                <a:solidFill>
+                  <a:srgbClr val="6E7F8B"/>
+                </a:solidFill>
+                <a:latin typeface="Calibri" pitchFamily="34" charset="0"/>
+                <a:ea typeface="Calibri" pitchFamily="34" charset="-122"/>
+                <a:cs typeface="Calibri" pitchFamily="34" charset="-120"/>
+              </a:rPr>
+              <a:t>EXAMPLE</a:t>
+            </a:r>
+            <a:endParaRPr lang="en-US" sz="1000" dirty="0"/>
+          </a:p>
+        </p:txBody>
+      </p:sp>
+      <p:sp>
+        <p:nvSpPr>
+          <p:cNvPr id="6" name="Text 4"/>
+          <p:cNvSpPr/>
+          <p:nvPr/>
+        </p:nvSpPr>
+        <p:spPr>
+          <a:xfrm>
+            <a:off x="6995160" y="1965960"/>
+            <a:ext cx="4480560" cy="274320"/>
+          </a:xfrm>
+          <a:prstGeom prst="rect">
+            <a:avLst/>
+          </a:prstGeom>
+          <a:noFill/>
+          <a:ln/>
+        </p:spPr>
+        <p:txBody>
+          <a:bodyPr wrap="square" lIns="0" tIns="0" rIns="0" bIns="0" rtlCol="0" anchor="ctr"/>
+          <a:lstStyle/>
+          <a:p>
+            <a:pPr indent="0" marL="0">
+              <a:buNone/>
+            </a:pPr>
+            <a:r>
+              <a:rPr lang="en-US" sz="1000" b="1" spc="150" kern="0" dirty="0">
+                <a:solidFill>
+                  <a:srgbClr val="6E7F8B"/>
+                </a:solidFill>
+                <a:latin typeface="Calibri" pitchFamily="34" charset="0"/>
+                <a:ea typeface="Calibri" pitchFamily="34" charset="-122"/>
+                <a:cs typeface="Calibri" pitchFamily="34" charset="-120"/>
+              </a:rPr>
+              <a:t>EFFECT ON HOLE PUNCHING</a:t>
+            </a:r>
+            <a:endParaRPr lang="en-US" sz="1000" dirty="0"/>
+          </a:p>
+        </p:txBody>
+      </p:sp>
+      <p:sp>
+        <p:nvSpPr>
+          <p:cNvPr id="7" name="Shape 5"/>
+          <p:cNvSpPr/>
+          <p:nvPr/>
+        </p:nvSpPr>
+        <p:spPr>
+          <a:xfrm>
+            <a:off x="548640" y="2276856"/>
+            <a:ext cx="11064240" cy="768096"/>
+          </a:xfrm>
+          <a:prstGeom prst="roundRect">
+            <a:avLst>
+              <a:gd name="adj" fmla="val 7143"/>
+            </a:avLst>
+          </a:prstGeom>
+          <a:solidFill>
+            <a:srgbClr val="F6F9F9"/>
+          </a:solidFill>
+          <a:ln w="6350">
+            <a:solidFill>
+              <a:srgbClr val="F6F9F9"/>
+            </a:solidFill>
+            <a:prstDash val="solid"/>
+          </a:ln>
+        </p:spPr>
+      </p:sp>
+      <p:sp>
+        <p:nvSpPr>
+          <p:cNvPr id="8" name="Text 6"/>
+          <p:cNvSpPr/>
+          <p:nvPr/>
+        </p:nvSpPr>
+        <p:spPr>
+          <a:xfrm>
+            <a:off x="685800" y="2331720"/>
+            <a:ext cx="3474720" cy="658368"/>
+          </a:xfrm>
+          <a:prstGeom prst="rect">
+            <a:avLst/>
+          </a:prstGeom>
+          <a:noFill/>
+          <a:ln/>
+        </p:spPr>
+        <p:txBody>
+          <a:bodyPr wrap="square" lIns="0" tIns="0" rIns="0" bIns="0" rtlCol="0" anchor="ctr"/>
+          <a:lstStyle/>
+          <a:p>
+            <a:pPr indent="0" marL="0">
+              <a:buNone/>
+            </a:pPr>
+            <a:r>
+              <a:rPr lang="en-US" sz="1500" b="1" dirty="0">
+                <a:solidFill>
+                  <a:srgbClr val="0E7C86"/>
+                </a:solidFill>
+                <a:latin typeface="Cambria" pitchFamily="34" charset="0"/>
+                <a:ea typeface="Cambria" pitchFamily="34" charset="-122"/>
+                <a:cs typeface="Cambria" pitchFamily="34" charset="-120"/>
+              </a:rPr>
+              <a:t>Endpoint-independent</a:t>
+            </a:r>
+            <a:endParaRPr lang="en-US" sz="1500" dirty="0"/>
+          </a:p>
+        </p:txBody>
+      </p:sp>
+      <p:sp>
+        <p:nvSpPr>
+          <p:cNvPr id="9" name="Text 7"/>
+          <p:cNvSpPr/>
+          <p:nvPr/>
+        </p:nvSpPr>
+        <p:spPr>
+          <a:xfrm>
+            <a:off x="4343400" y="2331720"/>
+            <a:ext cx="2468880" cy="658368"/>
+          </a:xfrm>
+          <a:prstGeom prst="rect">
+            <a:avLst/>
+          </a:prstGeom>
+          <a:noFill/>
+          <a:ln/>
+        </p:spPr>
+        <p:txBody>
+          <a:bodyPr wrap="square" lIns="0" tIns="0" rIns="0" bIns="0" rtlCol="0" anchor="ctr"/>
+          <a:lstStyle/>
+          <a:p>
+            <a:pPr indent="0" marL="0">
+              <a:buNone/>
+            </a:pPr>
+            <a:r>
+              <a:rPr lang="en-US" sz="1300" i="1" dirty="0">
+                <a:solidFill>
+                  <a:srgbClr val="6E7F8B"/>
+                </a:solidFill>
+                <a:latin typeface="Calibri" pitchFamily="34" charset="0"/>
+                <a:ea typeface="Calibri" pitchFamily="34" charset="-122"/>
+                <a:cs typeface="Calibri" pitchFamily="34" charset="-120"/>
+              </a:rPr>
+              <a:t>most home routers</a:t>
+            </a:r>
+            <a:endParaRPr lang="en-US" sz="1300" dirty="0"/>
+          </a:p>
+        </p:txBody>
+      </p:sp>
+      <p:sp>
+        <p:nvSpPr>
+          <p:cNvPr id="10" name="Text 8"/>
+          <p:cNvSpPr/>
+          <p:nvPr/>
+        </p:nvSpPr>
+        <p:spPr>
+          <a:xfrm>
+            <a:off x="6995160" y="2331720"/>
+            <a:ext cx="4480560" cy="658368"/>
+          </a:xfrm>
+          <a:prstGeom prst="rect">
+            <a:avLst/>
+          </a:prstGeom>
+          <a:noFill/>
+          <a:ln/>
+        </p:spPr>
+        <p:txBody>
+          <a:bodyPr wrap="square" lIns="0" tIns="0" rIns="0" bIns="0" rtlCol="0" anchor="ctr"/>
+          <a:lstStyle/>
+          <a:p>
+            <a:pPr indent="0" marL="0">
+              <a:buNone/>
+            </a:pPr>
+            <a:r>
+              <a:rPr lang="en-US" sz="1450" dirty="0">
+                <a:solidFill>
+                  <a:srgbClr val="3E4C57"/>
+                </a:solidFill>
+                <a:latin typeface="Calibri" pitchFamily="34" charset="0"/>
+                <a:ea typeface="Calibri" pitchFamily="34" charset="-122"/>
+                <a:cs typeface="Calibri" pitchFamily="34" charset="-120"/>
+              </a:rPr>
+              <a:t>One external port for every destination. Punching works.</a:t>
+            </a:r>
+            <a:endParaRPr lang="en-US" sz="1450" dirty="0"/>
+          </a:p>
+        </p:txBody>
+      </p:sp>
+      <p:sp>
+        <p:nvSpPr>
+          <p:cNvPr id="11" name="Text 9"/>
+          <p:cNvSpPr/>
+          <p:nvPr/>
+        </p:nvSpPr>
+        <p:spPr>
+          <a:xfrm>
+            <a:off x="685800" y="3172968"/>
+            <a:ext cx="3474720" cy="658368"/>
+          </a:xfrm>
+          <a:prstGeom prst="rect">
+            <a:avLst/>
+          </a:prstGeom>
+          <a:noFill/>
+          <a:ln/>
+        </p:spPr>
+        <p:txBody>
+          <a:bodyPr wrap="square" lIns="0" tIns="0" rIns="0" bIns="0" rtlCol="0" anchor="ctr"/>
+          <a:lstStyle/>
+          <a:p>
+            <a:pPr indent="0" marL="0">
+              <a:buNone/>
+            </a:pPr>
+            <a:r>
+              <a:rPr lang="en-US" sz="1500" b="1" dirty="0">
+                <a:solidFill>
+                  <a:srgbClr val="0E7C86"/>
+                </a:solidFill>
+                <a:latin typeface="Cambria" pitchFamily="34" charset="0"/>
+                <a:ea typeface="Cambria" pitchFamily="34" charset="-122"/>
+                <a:cs typeface="Cambria" pitchFamily="34" charset="-120"/>
+              </a:rPr>
+              <a:t>Address-dependent</a:t>
+            </a:r>
+            <a:endParaRPr lang="en-US" sz="1500" dirty="0"/>
+          </a:p>
+        </p:txBody>
+      </p:sp>
+      <p:sp>
+        <p:nvSpPr>
+          <p:cNvPr id="12" name="Text 10"/>
+          <p:cNvSpPr/>
+          <p:nvPr/>
+        </p:nvSpPr>
+        <p:spPr>
+          <a:xfrm>
+            <a:off x="4343400" y="3172968"/>
+            <a:ext cx="2468880" cy="658368"/>
+          </a:xfrm>
+          <a:prstGeom prst="rect">
+            <a:avLst/>
+          </a:prstGeom>
+          <a:noFill/>
+          <a:ln/>
+        </p:spPr>
+        <p:txBody>
+          <a:bodyPr wrap="square" lIns="0" tIns="0" rIns="0" bIns="0" rtlCol="0" anchor="ctr"/>
+          <a:lstStyle/>
+          <a:p>
+            <a:pPr indent="0" marL="0">
+              <a:buNone/>
+            </a:pPr>
+            <a:r>
+              <a:rPr lang="en-US" sz="1300" i="1" dirty="0">
+                <a:solidFill>
+                  <a:srgbClr val="6E7F8B"/>
+                </a:solidFill>
+                <a:latin typeface="Calibri" pitchFamily="34" charset="0"/>
+                <a:ea typeface="Calibri" pitchFamily="34" charset="-122"/>
+                <a:cs typeface="Calibri" pitchFamily="34" charset="-120"/>
+              </a:rPr>
+              <a:t>some enterprise NATs</a:t>
+            </a:r>
+            <a:endParaRPr lang="en-US" sz="1300" dirty="0"/>
+          </a:p>
+        </p:txBody>
+      </p:sp>
+      <p:sp>
+        <p:nvSpPr>
+          <p:cNvPr id="13" name="Text 11"/>
+          <p:cNvSpPr/>
+          <p:nvPr/>
+        </p:nvSpPr>
+        <p:spPr>
+          <a:xfrm>
+            <a:off x="6995160" y="3172968"/>
+            <a:ext cx="4480560" cy="658368"/>
+          </a:xfrm>
+          <a:prstGeom prst="rect">
+            <a:avLst/>
+          </a:prstGeom>
+          <a:noFill/>
+          <a:ln/>
+        </p:spPr>
+        <p:txBody>
+          <a:bodyPr wrap="square" lIns="0" tIns="0" rIns="0" bIns="0" rtlCol="0" anchor="ctr"/>
+          <a:lstStyle/>
+          <a:p>
+            <a:pPr indent="0" marL="0">
+              <a:buNone/>
+            </a:pPr>
+            <a:r>
+              <a:rPr lang="en-US" sz="1450" dirty="0">
+                <a:solidFill>
+                  <a:srgbClr val="3E4C57"/>
+                </a:solidFill>
+                <a:latin typeface="Calibri" pitchFamily="34" charset="0"/>
+                <a:ea typeface="Calibri" pitchFamily="34" charset="-122"/>
+                <a:cs typeface="Calibri" pitchFamily="34" charset="-120"/>
+              </a:rPr>
+              <a:t>A new port per destination address. Both sides must punch.</a:t>
+            </a:r>
+            <a:endParaRPr lang="en-US" sz="1450" dirty="0"/>
+          </a:p>
+        </p:txBody>
+      </p:sp>
+      <p:sp>
+        <p:nvSpPr>
+          <p:cNvPr id="14" name="Shape 12"/>
+          <p:cNvSpPr/>
+          <p:nvPr/>
+        </p:nvSpPr>
+        <p:spPr>
+          <a:xfrm>
+            <a:off x="548640" y="3959352"/>
+            <a:ext cx="11064240" cy="768096"/>
+          </a:xfrm>
+          <a:prstGeom prst="roundRect">
+            <a:avLst>
+              <a:gd name="adj" fmla="val 7143"/>
+            </a:avLst>
+          </a:prstGeom>
+          <a:solidFill>
+            <a:srgbClr val="F6F9F9"/>
+          </a:solidFill>
+          <a:ln w="6350">
+            <a:solidFill>
+              <a:srgbClr val="F6F9F9"/>
+            </a:solidFill>
+            <a:prstDash val="solid"/>
+          </a:ln>
+        </p:spPr>
+      </p:sp>
+      <p:sp>
+        <p:nvSpPr>
+          <p:cNvPr id="15" name="Text 13"/>
+          <p:cNvSpPr/>
+          <p:nvPr/>
+        </p:nvSpPr>
+        <p:spPr>
+          <a:xfrm>
+            <a:off x="685800" y="4014216"/>
+            <a:ext cx="3474720" cy="658368"/>
+          </a:xfrm>
+          <a:prstGeom prst="rect">
+            <a:avLst/>
+          </a:prstGeom>
+          <a:noFill/>
+          <a:ln/>
+        </p:spPr>
+        <p:txBody>
+          <a:bodyPr wrap="square" lIns="0" tIns="0" rIns="0" bIns="0" rtlCol="0" anchor="ctr"/>
+          <a:lstStyle/>
+          <a:p>
+            <a:pPr indent="0" marL="0">
+              <a:buNone/>
+            </a:pPr>
+            <a:r>
+              <a:rPr lang="en-US" sz="1500" b="1" dirty="0">
+                <a:solidFill>
+                  <a:srgbClr val="C25E28"/>
+                </a:solidFill>
+                <a:latin typeface="Cambria" pitchFamily="34" charset="0"/>
+                <a:ea typeface="Cambria" pitchFamily="34" charset="-122"/>
+                <a:cs typeface="Cambria" pitchFamily="34" charset="-120"/>
+              </a:rPr>
+              <a:t>Address-and-port-dependent</a:t>
+            </a:r>
+            <a:endParaRPr lang="en-US" sz="1500" dirty="0"/>
+          </a:p>
+        </p:txBody>
+      </p:sp>
+      <p:sp>
+        <p:nvSpPr>
+          <p:cNvPr id="16" name="Text 14"/>
+          <p:cNvSpPr/>
+          <p:nvPr/>
+        </p:nvSpPr>
+        <p:spPr>
+          <a:xfrm>
+            <a:off x="4343400" y="4014216"/>
+            <a:ext cx="2468880" cy="658368"/>
+          </a:xfrm>
+          <a:prstGeom prst="rect">
+            <a:avLst/>
+          </a:prstGeom>
+          <a:noFill/>
+          <a:ln/>
+        </p:spPr>
+        <p:txBody>
+          <a:bodyPr wrap="square" lIns="0" tIns="0" rIns="0" bIns="0" rtlCol="0" anchor="ctr"/>
+          <a:lstStyle/>
+          <a:p>
+            <a:pPr indent="0" marL="0">
+              <a:buNone/>
+            </a:pPr>
+            <a:r>
+              <a:rPr lang="en-US" sz="1300" i="1" dirty="0">
+                <a:solidFill>
+                  <a:srgbClr val="6E7F8B"/>
+                </a:solidFill>
+                <a:latin typeface="Calibri" pitchFamily="34" charset="0"/>
+                <a:ea typeface="Calibri" pitchFamily="34" charset="-122"/>
+                <a:cs typeface="Calibri" pitchFamily="34" charset="-120"/>
+              </a:rPr>
+              <a:t>many mobile carriers</a:t>
+            </a:r>
+            <a:endParaRPr lang="en-US" sz="1300" dirty="0"/>
+          </a:p>
+        </p:txBody>
+      </p:sp>
+      <p:sp>
+        <p:nvSpPr>
+          <p:cNvPr id="17" name="Text 15"/>
+          <p:cNvSpPr/>
+          <p:nvPr/>
+        </p:nvSpPr>
+        <p:spPr>
+          <a:xfrm>
+            <a:off x="6995160" y="4014216"/>
+            <a:ext cx="4480560" cy="658368"/>
+          </a:xfrm>
+          <a:prstGeom prst="rect">
+            <a:avLst/>
+          </a:prstGeom>
+          <a:noFill/>
+          <a:ln/>
+        </p:spPr>
+        <p:txBody>
+          <a:bodyPr wrap="square" lIns="0" tIns="0" rIns="0" bIns="0" rtlCol="0" anchor="ctr"/>
+          <a:lstStyle/>
+          <a:p>
+            <a:pPr indent="0" marL="0">
+              <a:buNone/>
+            </a:pPr>
+            <a:r>
+              <a:rPr lang="en-US" sz="1450" dirty="0">
+                <a:solidFill>
+                  <a:srgbClr val="3E4C57"/>
+                </a:solidFill>
+                <a:latin typeface="Calibri" pitchFamily="34" charset="0"/>
+                <a:ea typeface="Calibri" pitchFamily="34" charset="-122"/>
+                <a:cs typeface="Calibri" pitchFamily="34" charset="-120"/>
+              </a:rPr>
+              <a:t>A new port per endpoint. Punching fails without prediction.</a:t>
+            </a:r>
+            <a:endParaRPr lang="en-US" sz="1450" dirty="0"/>
+          </a:p>
+        </p:txBody>
+      </p:sp>
+      <p:sp>
+        <p:nvSpPr>
+          <p:cNvPr id="18" name="Text 16"/>
+          <p:cNvSpPr/>
+          <p:nvPr/>
+        </p:nvSpPr>
+        <p:spPr>
+          <a:xfrm>
+            <a:off x="685800" y="4855464"/>
+            <a:ext cx="3474720" cy="658368"/>
+          </a:xfrm>
+          <a:prstGeom prst="rect">
+            <a:avLst/>
+          </a:prstGeom>
+          <a:noFill/>
+          <a:ln/>
+        </p:spPr>
+        <p:txBody>
+          <a:bodyPr wrap="square" lIns="0" tIns="0" rIns="0" bIns="0" rtlCol="0" anchor="ctr"/>
+          <a:lstStyle/>
+          <a:p>
+            <a:pPr indent="0" marL="0">
+              <a:buNone/>
+            </a:pPr>
+            <a:r>
+              <a:rPr lang="en-US" sz="1500" b="1" dirty="0">
+                <a:solidFill>
+                  <a:srgbClr val="C25E28"/>
+                </a:solidFill>
+                <a:latin typeface="Cambria" pitchFamily="34" charset="0"/>
+                <a:ea typeface="Cambria" pitchFamily="34" charset="-122"/>
+                <a:cs typeface="Cambria" pitchFamily="34" charset="-120"/>
+              </a:rPr>
+              <a:t>Carrier-grade NAT</a:t>
+            </a:r>
+            <a:endParaRPr lang="en-US" sz="1500" dirty="0"/>
+          </a:p>
+        </p:txBody>
+      </p:sp>
+      <p:sp>
+        <p:nvSpPr>
+          <p:cNvPr id="19" name="Text 17"/>
+          <p:cNvSpPr/>
+          <p:nvPr/>
+        </p:nvSpPr>
+        <p:spPr>
+          <a:xfrm>
+            <a:off x="4343400" y="4855464"/>
+            <a:ext cx="2468880" cy="658368"/>
+          </a:xfrm>
+          <a:prstGeom prst="rect">
+            <a:avLst/>
+          </a:prstGeom>
+          <a:noFill/>
+          <a:ln/>
+        </p:spPr>
+        <p:txBody>
+          <a:bodyPr wrap="square" lIns="0" tIns="0" rIns="0" bIns="0" rtlCol="0" anchor="ctr"/>
+          <a:lstStyle/>
+          <a:p>
+            <a:pPr indent="0" marL="0">
+              <a:buNone/>
+            </a:pPr>
+            <a:r>
+              <a:rPr lang="en-US" sz="1300" i="1" dirty="0">
+                <a:solidFill>
+                  <a:srgbClr val="6E7F8B"/>
+                </a:solidFill>
+                <a:latin typeface="Calibri" pitchFamily="34" charset="0"/>
+                <a:ea typeface="Calibri" pitchFamily="34" charset="-122"/>
+                <a:cs typeface="Calibri" pitchFamily="34" charset="-120"/>
+              </a:rPr>
+              <a:t>prepaid mobile data</a:t>
+            </a:r>
+            <a:endParaRPr lang="en-US" sz="1300" dirty="0"/>
+          </a:p>
+        </p:txBody>
+      </p:sp>
+      <p:sp>
+        <p:nvSpPr>
+          <p:cNvPr id="20" name="Text 18"/>
+          <p:cNvSpPr/>
+          <p:nvPr/>
+        </p:nvSpPr>
+        <p:spPr>
+          <a:xfrm>
+            <a:off x="6995160" y="4855464"/>
+            <a:ext cx="4480560" cy="658368"/>
+          </a:xfrm>
+          <a:prstGeom prst="rect">
+            <a:avLst/>
+          </a:prstGeom>
+          <a:noFill/>
+          <a:ln/>
+        </p:spPr>
+        <p:txBody>
+          <a:bodyPr wrap="square" lIns="0" tIns="0" rIns="0" bIns="0" rtlCol="0" anchor="ctr"/>
+          <a:lstStyle/>
+          <a:p>
+            <a:pPr indent="0" marL="0">
+              <a:buNone/>
+            </a:pPr>
+            <a:r>
+              <a:rPr lang="en-US" sz="1450" dirty="0">
+                <a:solidFill>
+                  <a:srgbClr val="3E4C57"/>
+                </a:solidFill>
+                <a:latin typeface="Calibri" pitchFamily="34" charset="0"/>
+                <a:ea typeface="Calibri" pitchFamily="34" charset="-122"/>
+                <a:cs typeface="Calibri" pitchFamily="34" charset="-120"/>
+              </a:rPr>
+              <a:t>Stacked above all of it. No unsolicited inbound at all.</a:t>
+            </a:r>
+            <a:endParaRPr lang="en-US" sz="1450" dirty="0"/>
+          </a:p>
+        </p:txBody>
+      </p:sp>
+      <p:sp>
+        <p:nvSpPr>
+          <p:cNvPr id="21" name="Text 19"/>
+          <p:cNvSpPr/>
+          <p:nvPr/>
+        </p:nvSpPr>
+        <p:spPr>
+          <a:xfrm>
+            <a:off x="685800" y="5806440"/>
+            <a:ext cx="10789920" cy="365760"/>
+          </a:xfrm>
+          <a:prstGeom prst="rect">
+            <a:avLst/>
+          </a:prstGeom>
+          <a:noFill/>
+          <a:ln/>
+        </p:spPr>
+        <p:txBody>
+          <a:bodyPr wrap="square" lIns="0" tIns="0" rIns="0" bIns="0" rtlCol="0" anchor="ctr"/>
+          <a:lstStyle/>
+          <a:p>
+            <a:pPr indent="0" marL="0">
+              <a:buNone/>
+            </a:pPr>
+            <a:r>
+              <a:rPr lang="en-US" sz="1500" i="1" dirty="0">
+                <a:solidFill>
+                  <a:srgbClr val="0A5A62"/>
+                </a:solidFill>
+                <a:latin typeface="Calibri" pitchFamily="34" charset="0"/>
+                <a:ea typeface="Calibri" pitchFamily="34" charset="-122"/>
+                <a:cs typeface="Calibri" pitchFamily="34" charset="-120"/>
+              </a:rPr>
+              <a:t>We measure the tuple — mapping, filtering, port preservation, lifetime — never a single type.</a:t>
+            </a:r>
+            <a:endParaRPr lang="en-US" sz="1500" dirty="0"/>
+          </a:p>
+        </p:txBody>
+      </p:sp>
+    </p:spTree>
+  </p:cSld>
+  <p:clrMapOvr>
+    <a:masterClrMapping/>
+  </p:clrMapOvr>
+</p:sld>
+</file>
+
+<file path=ppt/slides/slide4.xml><?xml version="1.0" encoding="utf-8"?>
+<p:sld xmlns:a="http://schemas.openxmlformats.org/drawingml/2006/main" xmlns:r="http://schemas.openxmlformats.org/officeDocument/2006/relationships" xmlns:p="http://schemas.openxmlformats.org/presentationml/2006/main">
+  <p:cSld name="Slide 4">
     <p:bg>
       <p:bgPr>
         <a:solidFill>
@@ -3910,832 +4691,6 @@
               <a:t>Having a public address is not being reachable at it.</a:t>
             </a:r>
             <a:endParaRPr lang="en-US" sz="1700" dirty="0"/>
-          </a:p>
-        </p:txBody>
-      </p:sp>
-    </p:spTree>
-  </p:cSld>
-  <p:clrMapOvr>
-    <a:masterClrMapping/>
-  </p:clrMapOvr>
-</p:sld>
-</file>
-
-<file path=ppt/slides/slide4.xml><?xml version="1.0" encoding="utf-8"?>
-<p:sld xmlns:a="http://schemas.openxmlformats.org/drawingml/2006/main" xmlns:r="http://schemas.openxmlformats.org/officeDocument/2006/relationships" xmlns:p="http://schemas.openxmlformats.org/presentationml/2006/main">
-  <p:cSld name="Slide 4">
-    <p:spTree>
-      <p:nvGrpSpPr>
-        <p:cNvPr id="1" name=""/>
-        <p:cNvGrpSpPr/>
-        <p:nvPr/>
-      </p:nvGrpSpPr>
-      <p:grpSpPr>
-        <a:xfrm>
-          <a:off x="0" y="0"/>
-          <a:ext cx="0" cy="0"/>
-          <a:chOff x="0" y="0"/>
-          <a:chExt cx="0" cy="0"/>
-        </a:xfrm>
-      </p:grpSpPr>
-      <p:sp>
-        <p:nvSpPr>
-          <p:cNvPr id="2" name="Text 0"/>
-          <p:cNvSpPr/>
-          <p:nvPr/>
-        </p:nvSpPr>
-        <p:spPr>
-          <a:xfrm>
-            <a:off x="685800" y="502920"/>
-            <a:ext cx="10789920" cy="274320"/>
-          </a:xfrm>
-          <a:prstGeom prst="rect">
-            <a:avLst/>
-          </a:prstGeom>
-          <a:noFill/>
-          <a:ln/>
-        </p:spPr>
-        <p:txBody>
-          <a:bodyPr wrap="square" lIns="0" tIns="0" rIns="0" bIns="0" rtlCol="0" anchor="ctr"/>
-          <a:lstStyle/>
-          <a:p>
-            <a:pPr indent="0" marL="0">
-              <a:buNone/>
-            </a:pPr>
-            <a:r>
-              <a:rPr lang="en-US" sz="1100" b="1" spc="200" kern="0" dirty="0">
-                <a:solidFill>
-                  <a:srgbClr val="0E7C86"/>
-                </a:solidFill>
-                <a:latin typeface="Calibri" pitchFamily="34" charset="0"/>
-                <a:ea typeface="Calibri" pitchFamily="34" charset="-122"/>
-                <a:cs typeface="Calibri" pitchFamily="34" charset="-120"/>
-              </a:rPr>
-              <a:t>THE IDEA</a:t>
-            </a:r>
-            <a:endParaRPr lang="en-US" sz="1100" dirty="0"/>
-          </a:p>
-        </p:txBody>
-      </p:sp>
-      <p:sp>
-        <p:nvSpPr>
-          <p:cNvPr id="3" name="Text 1"/>
-          <p:cNvSpPr/>
-          <p:nvPr/>
-        </p:nvSpPr>
-        <p:spPr>
-          <a:xfrm>
-            <a:off x="685800" y="804672"/>
-            <a:ext cx="10789920" cy="822960"/>
-          </a:xfrm>
-          <a:prstGeom prst="rect">
-            <a:avLst/>
-          </a:prstGeom>
-          <a:noFill/>
-          <a:ln/>
-        </p:spPr>
-        <p:txBody>
-          <a:bodyPr wrap="square" lIns="0" tIns="0" rIns="0" bIns="0" rtlCol="0" anchor="ctr"/>
-          <a:lstStyle/>
-          <a:p>
-            <a:pPr indent="0" marL="0">
-              <a:buNone/>
-            </a:pPr>
-            <a:r>
-              <a:rPr lang="en-US" sz="3600" b="1" dirty="0">
-                <a:solidFill>
-                  <a:srgbClr val="16202A"/>
-                </a:solidFill>
-                <a:latin typeface="Cambria" pitchFamily="34" charset="0"/>
-                <a:ea typeface="Cambria" pitchFamily="34" charset="-122"/>
-                <a:cs typeface="Cambria" pitchFamily="34" charset="-120"/>
-              </a:rPr>
-              <a:t>Witness-based detection</a:t>
-            </a:r>
-            <a:endParaRPr lang="en-US" sz="3600" dirty="0"/>
-          </a:p>
-        </p:txBody>
-      </p:sp>
-      <p:sp>
-        <p:nvSpPr>
-          <p:cNvPr id="4" name="Shape 2"/>
-          <p:cNvSpPr/>
-          <p:nvPr/>
-        </p:nvSpPr>
-        <p:spPr>
-          <a:xfrm>
-            <a:off x="1051560" y="2880360"/>
-            <a:ext cx="2286000" cy="1005840"/>
-          </a:xfrm>
-          <a:prstGeom prst="roundRect">
-            <a:avLst>
-              <a:gd name="adj" fmla="val 5455"/>
-            </a:avLst>
-          </a:prstGeom>
-          <a:solidFill>
-            <a:srgbClr val="EEF3F4"/>
-          </a:solidFill>
-          <a:ln w="17780">
-            <a:solidFill>
-              <a:srgbClr val="0E7C86"/>
-            </a:solidFill>
-            <a:prstDash val="solid"/>
-          </a:ln>
-        </p:spPr>
-      </p:sp>
-      <p:sp>
-        <p:nvSpPr>
-          <p:cNvPr id="5" name="Text 3"/>
-          <p:cNvSpPr/>
-          <p:nvPr/>
-        </p:nvSpPr>
-        <p:spPr>
-          <a:xfrm>
-            <a:off x="1051560" y="3063240"/>
-            <a:ext cx="2286000" cy="329184"/>
-          </a:xfrm>
-          <a:prstGeom prst="rect">
-            <a:avLst/>
-          </a:prstGeom>
-          <a:noFill/>
-          <a:ln/>
-        </p:spPr>
-        <p:txBody>
-          <a:bodyPr wrap="square" lIns="0" tIns="0" rIns="0" bIns="0" rtlCol="0" anchor="ctr"/>
-          <a:lstStyle/>
-          <a:p>
-            <a:pPr algn="ctr" indent="0" marL="0">
-              <a:buNone/>
-            </a:pPr>
-            <a:r>
-              <a:rPr lang="en-US" sz="1700" b="1" dirty="0">
-                <a:solidFill>
-                  <a:srgbClr val="16202A"/>
-                </a:solidFill>
-                <a:latin typeface="Cambria" pitchFamily="34" charset="0"/>
-                <a:ea typeface="Cambria" pitchFamily="34" charset="-122"/>
-                <a:cs typeface="Cambria" pitchFamily="34" charset="-120"/>
-              </a:rPr>
-              <a:t>Probe</a:t>
-            </a:r>
-            <a:endParaRPr lang="en-US" sz="1700" dirty="0"/>
-          </a:p>
-        </p:txBody>
-      </p:sp>
-      <p:sp>
-        <p:nvSpPr>
-          <p:cNvPr id="6" name="Text 4"/>
-          <p:cNvSpPr/>
-          <p:nvPr/>
-        </p:nvSpPr>
-        <p:spPr>
-          <a:xfrm>
-            <a:off x="1051560" y="3410712"/>
-            <a:ext cx="2286000" cy="274320"/>
-          </a:xfrm>
-          <a:prstGeom prst="rect">
-            <a:avLst/>
-          </a:prstGeom>
-          <a:noFill/>
-          <a:ln/>
-        </p:spPr>
-        <p:txBody>
-          <a:bodyPr wrap="square" lIns="0" tIns="0" rIns="0" bIns="0" rtlCol="0" anchor="ctr"/>
-          <a:lstStyle/>
-          <a:p>
-            <a:pPr algn="ctr" indent="0" marL="0">
-              <a:buNone/>
-            </a:pPr>
-            <a:r>
-              <a:rPr lang="en-US" sz="1200" dirty="0">
-                <a:solidFill>
-                  <a:srgbClr val="6E7F8B"/>
-                </a:solidFill>
-                <a:latin typeface="Calibri" pitchFamily="34" charset="0"/>
-                <a:ea typeface="Calibri" pitchFamily="34" charset="-122"/>
-                <a:cs typeface="Calibri" pitchFamily="34" charset="-120"/>
-              </a:rPr>
-              <a:t>the device</a:t>
-            </a:r>
-            <a:endParaRPr lang="en-US" sz="1200" dirty="0"/>
-          </a:p>
-        </p:txBody>
-      </p:sp>
-      <p:sp>
-        <p:nvSpPr>
-          <p:cNvPr id="7" name="Shape 5"/>
-          <p:cNvSpPr/>
-          <p:nvPr/>
-        </p:nvSpPr>
-        <p:spPr>
-          <a:xfrm>
-            <a:off x="8275320" y="1965960"/>
-            <a:ext cx="3017520" cy="868680"/>
-          </a:xfrm>
-          <a:prstGeom prst="roundRect">
-            <a:avLst>
-              <a:gd name="adj" fmla="val 6316"/>
-            </a:avLst>
-          </a:prstGeom>
-          <a:solidFill>
-            <a:srgbClr val="EEF3F4"/>
-          </a:solidFill>
-          <a:ln w="16510">
-            <a:solidFill>
-              <a:srgbClr val="0E7C86"/>
-            </a:solidFill>
-            <a:prstDash val="solid"/>
-          </a:ln>
-        </p:spPr>
-      </p:sp>
-      <p:sp>
-        <p:nvSpPr>
-          <p:cNvPr id="8" name="Text 6"/>
-          <p:cNvSpPr/>
-          <p:nvPr/>
-        </p:nvSpPr>
-        <p:spPr>
-          <a:xfrm>
-            <a:off x="8412480" y="2093976"/>
-            <a:ext cx="2743200" cy="292608"/>
-          </a:xfrm>
-          <a:prstGeom prst="rect">
-            <a:avLst/>
-          </a:prstGeom>
-          <a:noFill/>
-          <a:ln/>
-        </p:spPr>
-        <p:txBody>
-          <a:bodyPr wrap="square" lIns="0" tIns="0" rIns="0" bIns="0" rtlCol="0" anchor="ctr"/>
-          <a:lstStyle/>
-          <a:p>
-            <a:pPr indent="0" marL="0">
-              <a:buNone/>
-            </a:pPr>
-            <a:r>
-              <a:rPr lang="en-US" sz="1500" b="1" dirty="0">
-                <a:solidFill>
-                  <a:srgbClr val="16202A"/>
-                </a:solidFill>
-                <a:latin typeface="Cambria" pitchFamily="34" charset="0"/>
-                <a:ea typeface="Cambria" pitchFamily="34" charset="-122"/>
-                <a:cs typeface="Cambria" pitchFamily="34" charset="-120"/>
-              </a:rPr>
-              <a:t>Friend A</a:t>
-            </a:r>
-            <a:endParaRPr lang="en-US" sz="1500" dirty="0"/>
-          </a:p>
-        </p:txBody>
-      </p:sp>
-      <p:sp>
-        <p:nvSpPr>
-          <p:cNvPr id="9" name="Text 7"/>
-          <p:cNvSpPr/>
-          <p:nvPr/>
-        </p:nvSpPr>
-        <p:spPr>
-          <a:xfrm>
-            <a:off x="8412480" y="2404872"/>
-            <a:ext cx="2743200" cy="274320"/>
-          </a:xfrm>
-          <a:prstGeom prst="rect">
-            <a:avLst/>
-          </a:prstGeom>
-          <a:noFill/>
-          <a:ln/>
-        </p:spPr>
-        <p:txBody>
-          <a:bodyPr wrap="square" lIns="0" tIns="0" rIns="0" bIns="0" rtlCol="0" anchor="ctr"/>
-          <a:lstStyle/>
-          <a:p>
-            <a:pPr indent="0" marL="0">
-              <a:buNone/>
-            </a:pPr>
-            <a:r>
-              <a:rPr lang="en-US" sz="1150" dirty="0">
-                <a:solidFill>
-                  <a:srgbClr val="0E7C86"/>
-                </a:solidFill>
-                <a:latin typeface="Calibri" pitchFamily="34" charset="0"/>
-                <a:ea typeface="Calibri" pitchFamily="34" charset="-122"/>
-                <a:cs typeface="Calibri" pitchFamily="34" charset="-120"/>
-              </a:rPr>
-              <a:t>session open</a:t>
-            </a:r>
-            <a:endParaRPr lang="en-US" sz="1150" dirty="0"/>
-          </a:p>
-        </p:txBody>
-      </p:sp>
-      <p:sp>
-        <p:nvSpPr>
-          <p:cNvPr id="10" name="Shape 8"/>
-          <p:cNvSpPr/>
-          <p:nvPr/>
-        </p:nvSpPr>
-        <p:spPr>
-          <a:xfrm flipV="1">
-            <a:off x="3337560" y="2400300"/>
-            <a:ext cx="4937760" cy="982980"/>
-          </a:xfrm>
-          <a:prstGeom prst="line">
-            <a:avLst/>
-          </a:prstGeom>
-          <a:noFill/>
-          <a:ln w="17780">
-            <a:solidFill>
-              <a:srgbClr val="0E7C86"/>
-            </a:solidFill>
-            <a:prstDash val="solid"/>
-            <a:headEnd type="triangle"/>
-          </a:ln>
-        </p:spPr>
-      </p:sp>
-      <p:sp>
-        <p:nvSpPr>
-          <p:cNvPr id="11" name="Shape 9"/>
-          <p:cNvSpPr/>
-          <p:nvPr/>
-        </p:nvSpPr>
-        <p:spPr>
-          <a:xfrm>
-            <a:off x="8275320" y="3063240"/>
-            <a:ext cx="3017520" cy="868680"/>
-          </a:xfrm>
-          <a:prstGeom prst="roundRect">
-            <a:avLst>
-              <a:gd name="adj" fmla="val 6316"/>
-            </a:avLst>
-          </a:prstGeom>
-          <a:solidFill>
-            <a:srgbClr val="EEF3F4"/>
-          </a:solidFill>
-          <a:ln w="16510">
-            <a:solidFill>
-              <a:srgbClr val="0E7C86"/>
-            </a:solidFill>
-            <a:prstDash val="solid"/>
-          </a:ln>
-        </p:spPr>
-      </p:sp>
-      <p:sp>
-        <p:nvSpPr>
-          <p:cNvPr id="12" name="Text 10"/>
-          <p:cNvSpPr/>
-          <p:nvPr/>
-        </p:nvSpPr>
-        <p:spPr>
-          <a:xfrm>
-            <a:off x="8412480" y="3191256"/>
-            <a:ext cx="2743200" cy="292608"/>
-          </a:xfrm>
-          <a:prstGeom prst="rect">
-            <a:avLst/>
-          </a:prstGeom>
-          <a:noFill/>
-          <a:ln/>
-        </p:spPr>
-        <p:txBody>
-          <a:bodyPr wrap="square" lIns="0" tIns="0" rIns="0" bIns="0" rtlCol="0" anchor="ctr"/>
-          <a:lstStyle/>
-          <a:p>
-            <a:pPr indent="0" marL="0">
-              <a:buNone/>
-            </a:pPr>
-            <a:r>
-              <a:rPr lang="en-US" sz="1500" b="1" dirty="0">
-                <a:solidFill>
-                  <a:srgbClr val="16202A"/>
-                </a:solidFill>
-                <a:latin typeface="Cambria" pitchFamily="34" charset="0"/>
-                <a:ea typeface="Cambria" pitchFamily="34" charset="-122"/>
-                <a:cs typeface="Cambria" pitchFamily="34" charset="-120"/>
-              </a:rPr>
-              <a:t>Friend B</a:t>
-            </a:r>
-            <a:endParaRPr lang="en-US" sz="1500" dirty="0"/>
-          </a:p>
-        </p:txBody>
-      </p:sp>
-      <p:sp>
-        <p:nvSpPr>
-          <p:cNvPr id="13" name="Text 11"/>
-          <p:cNvSpPr/>
-          <p:nvPr/>
-        </p:nvSpPr>
-        <p:spPr>
-          <a:xfrm>
-            <a:off x="8412480" y="3502152"/>
-            <a:ext cx="2743200" cy="274320"/>
-          </a:xfrm>
-          <a:prstGeom prst="rect">
-            <a:avLst/>
-          </a:prstGeom>
-          <a:noFill/>
-          <a:ln/>
-        </p:spPr>
-        <p:txBody>
-          <a:bodyPr wrap="square" lIns="0" tIns="0" rIns="0" bIns="0" rtlCol="0" anchor="ctr"/>
-          <a:lstStyle/>
-          <a:p>
-            <a:pPr indent="0" marL="0">
-              <a:buNone/>
-            </a:pPr>
-            <a:r>
-              <a:rPr lang="en-US" sz="1150" dirty="0">
-                <a:solidFill>
-                  <a:srgbClr val="0E7C86"/>
-                </a:solidFill>
-                <a:latin typeface="Calibri" pitchFamily="34" charset="0"/>
-                <a:ea typeface="Calibri" pitchFamily="34" charset="-122"/>
-                <a:cs typeface="Calibri" pitchFamily="34" charset="-120"/>
-              </a:rPr>
-              <a:t>new source port</a:t>
-            </a:r>
-            <a:endParaRPr lang="en-US" sz="1150" dirty="0"/>
-          </a:p>
-        </p:txBody>
-      </p:sp>
-      <p:sp>
-        <p:nvSpPr>
-          <p:cNvPr id="14" name="Shape 12"/>
-          <p:cNvSpPr/>
-          <p:nvPr/>
-        </p:nvSpPr>
-        <p:spPr>
-          <a:xfrm>
-            <a:off x="3337560" y="3383280"/>
-            <a:ext cx="4937760" cy="114300"/>
-          </a:xfrm>
-          <a:prstGeom prst="line">
-            <a:avLst/>
-          </a:prstGeom>
-          <a:noFill/>
-          <a:ln w="17780">
-            <a:solidFill>
-              <a:srgbClr val="0E7C86"/>
-            </a:solidFill>
-            <a:prstDash val="solid"/>
-            <a:headEnd type="triangle"/>
-          </a:ln>
-        </p:spPr>
-      </p:sp>
-      <p:sp>
-        <p:nvSpPr>
-          <p:cNvPr id="15" name="Shape 13"/>
-          <p:cNvSpPr/>
-          <p:nvPr/>
-        </p:nvSpPr>
-        <p:spPr>
-          <a:xfrm>
-            <a:off x="8275320" y="4160520"/>
-            <a:ext cx="3017520" cy="868680"/>
-          </a:xfrm>
-          <a:prstGeom prst="roundRect">
-            <a:avLst>
-              <a:gd name="adj" fmla="val 6316"/>
-            </a:avLst>
-          </a:prstGeom>
-          <a:solidFill>
-            <a:srgbClr val="EEF3F4"/>
-          </a:solidFill>
-          <a:ln w="16510">
-            <a:solidFill>
-              <a:srgbClr val="C25E28"/>
-            </a:solidFill>
-            <a:prstDash val="solid"/>
-          </a:ln>
-        </p:spPr>
-      </p:sp>
-      <p:sp>
-        <p:nvSpPr>
-          <p:cNvPr id="16" name="Text 14"/>
-          <p:cNvSpPr/>
-          <p:nvPr/>
-        </p:nvSpPr>
-        <p:spPr>
-          <a:xfrm>
-            <a:off x="8412480" y="4288536"/>
-            <a:ext cx="2743200" cy="292608"/>
-          </a:xfrm>
-          <a:prstGeom prst="rect">
-            <a:avLst/>
-          </a:prstGeom>
-          <a:noFill/>
-          <a:ln/>
-        </p:spPr>
-        <p:txBody>
-          <a:bodyPr wrap="square" lIns="0" tIns="0" rIns="0" bIns="0" rtlCol="0" anchor="ctr"/>
-          <a:lstStyle/>
-          <a:p>
-            <a:pPr indent="0" marL="0">
-              <a:buNone/>
-            </a:pPr>
-            <a:r>
-              <a:rPr lang="en-US" sz="1500" b="1" dirty="0">
-                <a:solidFill>
-                  <a:srgbClr val="16202A"/>
-                </a:solidFill>
-                <a:latin typeface="Cambria" pitchFamily="34" charset="0"/>
-                <a:ea typeface="Cambria" pitchFamily="34" charset="-122"/>
-                <a:cs typeface="Cambria" pitchFamily="34" charset="-120"/>
-              </a:rPr>
-              <a:t>Friend C</a:t>
-            </a:r>
-            <a:endParaRPr lang="en-US" sz="1500" dirty="0"/>
-          </a:p>
-        </p:txBody>
-      </p:sp>
-      <p:sp>
-        <p:nvSpPr>
-          <p:cNvPr id="17" name="Text 15"/>
-          <p:cNvSpPr/>
-          <p:nvPr/>
-        </p:nvSpPr>
-        <p:spPr>
-          <a:xfrm>
-            <a:off x="8412480" y="4599432"/>
-            <a:ext cx="2743200" cy="274320"/>
-          </a:xfrm>
-          <a:prstGeom prst="rect">
-            <a:avLst/>
-          </a:prstGeom>
-          <a:noFill/>
-          <a:ln/>
-        </p:spPr>
-        <p:txBody>
-          <a:bodyPr wrap="square" lIns="0" tIns="0" rIns="0" bIns="0" rtlCol="0" anchor="ctr"/>
-          <a:lstStyle/>
-          <a:p>
-            <a:pPr indent="0" marL="0">
-              <a:buNone/>
-            </a:pPr>
-            <a:r>
-              <a:rPr lang="en-US" sz="1150" dirty="0">
-                <a:solidFill>
-                  <a:srgbClr val="C25E28"/>
-                </a:solidFill>
-                <a:latin typeface="Calibri" pitchFamily="34" charset="0"/>
-                <a:ea typeface="Calibri" pitchFamily="34" charset="-122"/>
-                <a:cs typeface="Calibri" pitchFamily="34" charset="-120"/>
-              </a:rPr>
-              <a:t>never contacted</a:t>
-            </a:r>
-            <a:endParaRPr lang="en-US" sz="1150" dirty="0"/>
-          </a:p>
-        </p:txBody>
-      </p:sp>
-      <p:sp>
-        <p:nvSpPr>
-          <p:cNvPr id="18" name="Shape 16"/>
-          <p:cNvSpPr/>
-          <p:nvPr/>
-        </p:nvSpPr>
-        <p:spPr>
-          <a:xfrm>
-            <a:off x="3337560" y="3383280"/>
-            <a:ext cx="4937760" cy="1211580"/>
-          </a:xfrm>
-          <a:prstGeom prst="line">
-            <a:avLst/>
-          </a:prstGeom>
-          <a:noFill/>
-          <a:ln w="17780">
-            <a:solidFill>
-              <a:srgbClr val="C25E28"/>
-            </a:solidFill>
-            <a:prstDash val="solid"/>
-            <a:headEnd type="triangle"/>
-          </a:ln>
-        </p:spPr>
-      </p:sp>
-      <p:sp>
-        <p:nvSpPr>
-          <p:cNvPr id="19" name="Text 17"/>
-          <p:cNvSpPr/>
-          <p:nvPr/>
-        </p:nvSpPr>
-        <p:spPr>
-          <a:xfrm>
-            <a:off x="1051560" y="4069080"/>
-            <a:ext cx="2286000" cy="274320"/>
-          </a:xfrm>
-          <a:prstGeom prst="rect">
-            <a:avLst/>
-          </a:prstGeom>
-          <a:noFill/>
-          <a:ln/>
-        </p:spPr>
-        <p:txBody>
-          <a:bodyPr wrap="square" lIns="0" tIns="0" rIns="0" bIns="0" rtlCol="0" anchor="ctr"/>
-          <a:lstStyle/>
-          <a:p>
-            <a:pPr algn="ctr" indent="0" marL="0">
-              <a:buNone/>
-            </a:pPr>
-            <a:r>
-              <a:rPr lang="en-US" sz="1150" dirty="0">
-                <a:solidFill>
-                  <a:srgbClr val="6E7F8B"/>
-                </a:solidFill>
-                <a:latin typeface="Calibri" pitchFamily="34" charset="0"/>
-                <a:ea typeface="Calibri" pitchFamily="34" charset="-122"/>
-                <a:cs typeface="Calibri" pitchFamily="34" charset="-120"/>
-              </a:rPr>
-              <a:t>each dial-back carries the nonce</a:t>
-            </a:r>
-            <a:endParaRPr lang="en-US" sz="1150" dirty="0"/>
-          </a:p>
-        </p:txBody>
-      </p:sp>
-      <p:sp>
-        <p:nvSpPr>
-          <p:cNvPr id="20" name="Shape 18"/>
-          <p:cNvSpPr/>
-          <p:nvPr/>
-        </p:nvSpPr>
-        <p:spPr>
-          <a:xfrm>
-            <a:off x="685800" y="5376672"/>
-            <a:ext cx="118872" cy="118872"/>
-          </a:xfrm>
-          <a:prstGeom prst="ellipse">
-            <a:avLst/>
-          </a:prstGeom>
-          <a:solidFill>
-            <a:srgbClr val="0E7C86"/>
-          </a:solidFill>
-          <a:ln w="12700">
-            <a:solidFill>
-              <a:srgbClr val="0E7C86"/>
-            </a:solidFill>
-            <a:prstDash val="solid"/>
-          </a:ln>
-        </p:spPr>
-      </p:sp>
-      <p:sp>
-        <p:nvSpPr>
-          <p:cNvPr id="21" name="Text 19"/>
-          <p:cNvSpPr/>
-          <p:nvPr/>
-        </p:nvSpPr>
-        <p:spPr>
-          <a:xfrm>
-            <a:off x="1005840" y="5257800"/>
-            <a:ext cx="10469880" cy="384048"/>
-          </a:xfrm>
-          <a:prstGeom prst="rect">
-            <a:avLst/>
-          </a:prstGeom>
-          <a:noFill/>
-          <a:ln/>
-        </p:spPr>
-        <p:txBody>
-          <a:bodyPr wrap="square" lIns="0" tIns="0" rIns="0" bIns="0" rtlCol="0" anchor="ctr"/>
-          <a:lstStyle/>
-          <a:p>
-            <a:pPr indent="0" marL="0">
-              <a:buNone/>
-            </a:pPr>
-            <a:r>
-              <a:rPr lang="en-US" sz="1650" dirty="0">
-                <a:solidFill>
-                  <a:srgbClr val="3E4C57"/>
-                </a:solidFill>
-                <a:latin typeface="Calibri" pitchFamily="34" charset="0"/>
-                <a:ea typeface="Calibri" pitchFamily="34" charset="-122"/>
-                <a:cs typeface="Calibri" pitchFamily="34" charset="-120"/>
-              </a:rPr>
-              <a:t>Only friends. The probe asks each of them directly.</a:t>
-            </a:r>
-            <a:endParaRPr lang="en-US" sz="1650" dirty="0"/>
-          </a:p>
-        </p:txBody>
-      </p:sp>
-      <p:sp>
-        <p:nvSpPr>
-          <p:cNvPr id="22" name="Shape 20"/>
-          <p:cNvSpPr/>
-          <p:nvPr/>
-        </p:nvSpPr>
-        <p:spPr>
-          <a:xfrm>
-            <a:off x="685800" y="5779008"/>
-            <a:ext cx="118872" cy="118872"/>
-          </a:xfrm>
-          <a:prstGeom prst="ellipse">
-            <a:avLst/>
-          </a:prstGeom>
-          <a:solidFill>
-            <a:srgbClr val="0E7C86"/>
-          </a:solidFill>
-          <a:ln w="12700">
-            <a:solidFill>
-              <a:srgbClr val="0E7C86"/>
-            </a:solidFill>
-            <a:prstDash val="solid"/>
-          </a:ln>
-        </p:spPr>
-      </p:sp>
-      <p:sp>
-        <p:nvSpPr>
-          <p:cNvPr id="23" name="Text 21"/>
-          <p:cNvSpPr/>
-          <p:nvPr/>
-        </p:nvSpPr>
-        <p:spPr>
-          <a:xfrm>
-            <a:off x="1005840" y="5660136"/>
-            <a:ext cx="10469880" cy="384048"/>
-          </a:xfrm>
-          <a:prstGeom prst="rect">
-            <a:avLst/>
-          </a:prstGeom>
-          <a:noFill/>
-          <a:ln/>
-        </p:spPr>
-        <p:txBody>
-          <a:bodyPr wrap="square" lIns="0" tIns="0" rIns="0" bIns="0" rtlCol="0" anchor="ctr"/>
-          <a:lstStyle/>
-          <a:p>
-            <a:pPr indent="0" marL="0">
-              <a:buNone/>
-            </a:pPr>
-            <a:r>
-              <a:rPr lang="en-US" sz="1650" dirty="0">
-                <a:solidFill>
-                  <a:srgbClr val="3E4C57"/>
-                </a:solidFill>
-                <a:latin typeface="Calibri" pitchFamily="34" charset="0"/>
-                <a:ea typeface="Calibri" pitchFamily="34" charset="-122"/>
-                <a:cs typeface="Calibri" pitchFamily="34" charset="-120"/>
-              </a:rPr>
-              <a:t>They dial back from different addresses and ports.</a:t>
-            </a:r>
-            <a:endParaRPr lang="en-US" sz="1650" dirty="0"/>
-          </a:p>
-        </p:txBody>
-      </p:sp>
-      <p:sp>
-        <p:nvSpPr>
-          <p:cNvPr id="24" name="Shape 22"/>
-          <p:cNvSpPr/>
-          <p:nvPr/>
-        </p:nvSpPr>
-        <p:spPr>
-          <a:xfrm>
-            <a:off x="685800" y="6181344"/>
-            <a:ext cx="118872" cy="118872"/>
-          </a:xfrm>
-          <a:prstGeom prst="ellipse">
-            <a:avLst/>
-          </a:prstGeom>
-          <a:solidFill>
-            <a:srgbClr val="0E7C86"/>
-          </a:solidFill>
-          <a:ln w="12700">
-            <a:solidFill>
-              <a:srgbClr val="0E7C86"/>
-            </a:solidFill>
-            <a:prstDash val="solid"/>
-          </a:ln>
-        </p:spPr>
-      </p:sp>
-      <p:sp>
-        <p:nvSpPr>
-          <p:cNvPr id="25" name="Text 23"/>
-          <p:cNvSpPr/>
-          <p:nvPr/>
-        </p:nvSpPr>
-        <p:spPr>
-          <a:xfrm>
-            <a:off x="1005840" y="6062472"/>
-            <a:ext cx="10469880" cy="384048"/>
-          </a:xfrm>
-          <a:prstGeom prst="rect">
-            <a:avLst/>
-          </a:prstGeom>
-          <a:noFill/>
-          <a:ln/>
-        </p:spPr>
-        <p:txBody>
-          <a:bodyPr wrap="square" lIns="0" tIns="0" rIns="0" bIns="0" rtlCol="0" anchor="ctr"/>
-          <a:lstStyle/>
-          <a:p>
-            <a:pPr indent="0" marL="0">
-              <a:buNone/>
-            </a:pPr>
-            <a:r>
-              <a:rPr lang="en-US" sz="1650" dirty="0">
-                <a:solidFill>
-                  <a:srgbClr val="3E4C57"/>
-                </a:solidFill>
-                <a:latin typeface="Calibri" pitchFamily="34" charset="0"/>
-                <a:ea typeface="Calibri" pitchFamily="34" charset="-122"/>
-                <a:cs typeface="Calibri" pitchFamily="34" charset="-120"/>
-              </a:rPr>
-              <a:t>A nonce in each reply makes a fabricated dial-back impossible.</a:t>
-            </a:r>
-            <a:endParaRPr lang="en-US" sz="1650" dirty="0"/>
           </a:p>
         </p:txBody>
       </p:sp>
@@ -4797,7 +4752,7 @@
                 <a:ea typeface="Calibri" pitchFamily="34" charset="-122"/>
                 <a:cs typeface="Calibri" pitchFamily="34" charset="-120"/>
               </a:rPr>
-              <a:t>WHAT COULD INVALIDATE THE RESULT</a:t>
+              <a:t>THE IDEA</a:t>
             </a:r>
             <a:endParaRPr lang="en-US" sz="1100" dirty="0"/>
           </a:p>
@@ -4836,7 +4791,7 @@
                 <a:ea typeface="Cambria" pitchFamily="34" charset="-122"/>
                 <a:cs typeface="Cambria" pitchFamily="34" charset="-120"/>
               </a:rPr>
-              <a:t>Two validity threats</a:t>
+              <a:t>Witness-based detection</a:t>
             </a:r>
             <a:endParaRPr lang="en-US" sz="3600" dirty="0"/>
           </a:p>
@@ -4850,20 +4805,20 @@
         </p:nvSpPr>
         <p:spPr>
           <a:xfrm>
-            <a:off x="685800" y="2103120"/>
-            <a:ext cx="5212080" cy="2651760"/>
+            <a:off x="1051560" y="2880360"/>
+            <a:ext cx="2286000" cy="1005840"/>
           </a:xfrm>
           <a:prstGeom prst="roundRect">
             <a:avLst>
-              <a:gd name="adj" fmla="val 2069"/>
+              <a:gd name="adj" fmla="val 5455"/>
             </a:avLst>
           </a:prstGeom>
           <a:solidFill>
             <a:srgbClr val="EEF3F4"/>
           </a:solidFill>
-          <a:ln w="6350">
+          <a:ln w="17780">
             <a:solidFill>
-              <a:srgbClr val="EEF3F4"/>
+              <a:srgbClr val="0E7C86"/>
             </a:solidFill>
             <a:prstDash val="solid"/>
           </a:ln>
@@ -4871,22 +4826,360 @@
       </p:sp>
       <p:sp>
         <p:nvSpPr>
-          <p:cNvPr id="5" name="Shape 3"/>
-          <p:cNvSpPr/>
-          <p:nvPr/>
-        </p:nvSpPr>
-        <p:spPr>
-          <a:xfrm>
-            <a:off x="1051560" y="2377440"/>
-            <a:ext cx="365760" cy="365760"/>
-          </a:xfrm>
-          <a:prstGeom prst="ellipse">
-            <a:avLst/>
+          <p:cNvPr id="5" name="Text 3"/>
+          <p:cNvSpPr/>
+          <p:nvPr/>
+        </p:nvSpPr>
+        <p:spPr>
+          <a:xfrm>
+            <a:off x="1051560" y="3063240"/>
+            <a:ext cx="2286000" cy="329184"/>
+          </a:xfrm>
+          <a:prstGeom prst="rect">
+            <a:avLst/>
+          </a:prstGeom>
+          <a:noFill/>
+          <a:ln/>
+        </p:spPr>
+        <p:txBody>
+          <a:bodyPr wrap="square" lIns="0" tIns="0" rIns="0" bIns="0" rtlCol="0" anchor="ctr"/>
+          <a:lstStyle/>
+          <a:p>
+            <a:pPr algn="ctr" indent="0" marL="0">
+              <a:buNone/>
+            </a:pPr>
+            <a:r>
+              <a:rPr lang="en-US" sz="1700" b="1" dirty="0">
+                <a:solidFill>
+                  <a:srgbClr val="16202A"/>
+                </a:solidFill>
+                <a:latin typeface="Cambria" pitchFamily="34" charset="0"/>
+                <a:ea typeface="Cambria" pitchFamily="34" charset="-122"/>
+                <a:cs typeface="Cambria" pitchFamily="34" charset="-120"/>
+              </a:rPr>
+              <a:t>Probe</a:t>
+            </a:r>
+            <a:endParaRPr lang="en-US" sz="1700" dirty="0"/>
+          </a:p>
+        </p:txBody>
+      </p:sp>
+      <p:sp>
+        <p:nvSpPr>
+          <p:cNvPr id="6" name="Text 4"/>
+          <p:cNvSpPr/>
+          <p:nvPr/>
+        </p:nvSpPr>
+        <p:spPr>
+          <a:xfrm>
+            <a:off x="1051560" y="3410712"/>
+            <a:ext cx="2286000" cy="274320"/>
+          </a:xfrm>
+          <a:prstGeom prst="rect">
+            <a:avLst/>
+          </a:prstGeom>
+          <a:noFill/>
+          <a:ln/>
+        </p:spPr>
+        <p:txBody>
+          <a:bodyPr wrap="square" lIns="0" tIns="0" rIns="0" bIns="0" rtlCol="0" anchor="ctr"/>
+          <a:lstStyle/>
+          <a:p>
+            <a:pPr algn="ctr" indent="0" marL="0">
+              <a:buNone/>
+            </a:pPr>
+            <a:r>
+              <a:rPr lang="en-US" sz="1200" dirty="0">
+                <a:solidFill>
+                  <a:srgbClr val="6E7F8B"/>
+                </a:solidFill>
+                <a:latin typeface="Calibri" pitchFamily="34" charset="0"/>
+                <a:ea typeface="Calibri" pitchFamily="34" charset="-122"/>
+                <a:cs typeface="Calibri" pitchFamily="34" charset="-120"/>
+              </a:rPr>
+              <a:t>the device</a:t>
+            </a:r>
+            <a:endParaRPr lang="en-US" sz="1200" dirty="0"/>
+          </a:p>
+        </p:txBody>
+      </p:sp>
+      <p:sp>
+        <p:nvSpPr>
+          <p:cNvPr id="7" name="Shape 5"/>
+          <p:cNvSpPr/>
+          <p:nvPr/>
+        </p:nvSpPr>
+        <p:spPr>
+          <a:xfrm>
+            <a:off x="8275320" y="1965960"/>
+            <a:ext cx="3017520" cy="868680"/>
+          </a:xfrm>
+          <a:prstGeom prst="roundRect">
+            <a:avLst>
+              <a:gd name="adj" fmla="val 6316"/>
+            </a:avLst>
           </a:prstGeom>
           <a:solidFill>
-            <a:srgbClr val="C25E28"/>
+            <a:srgbClr val="EEF3F4"/>
           </a:solidFill>
-          <a:ln w="12700">
+          <a:ln w="16510">
+            <a:solidFill>
+              <a:srgbClr val="0E7C86"/>
+            </a:solidFill>
+            <a:prstDash val="solid"/>
+          </a:ln>
+        </p:spPr>
+      </p:sp>
+      <p:sp>
+        <p:nvSpPr>
+          <p:cNvPr id="8" name="Text 6"/>
+          <p:cNvSpPr/>
+          <p:nvPr/>
+        </p:nvSpPr>
+        <p:spPr>
+          <a:xfrm>
+            <a:off x="8412480" y="2093976"/>
+            <a:ext cx="2743200" cy="292608"/>
+          </a:xfrm>
+          <a:prstGeom prst="rect">
+            <a:avLst/>
+          </a:prstGeom>
+          <a:noFill/>
+          <a:ln/>
+        </p:spPr>
+        <p:txBody>
+          <a:bodyPr wrap="square" lIns="0" tIns="0" rIns="0" bIns="0" rtlCol="0" anchor="ctr"/>
+          <a:lstStyle/>
+          <a:p>
+            <a:pPr indent="0" marL="0">
+              <a:buNone/>
+            </a:pPr>
+            <a:r>
+              <a:rPr lang="en-US" sz="1500" b="1" dirty="0">
+                <a:solidFill>
+                  <a:srgbClr val="16202A"/>
+                </a:solidFill>
+                <a:latin typeface="Cambria" pitchFamily="34" charset="0"/>
+                <a:ea typeface="Cambria" pitchFamily="34" charset="-122"/>
+                <a:cs typeface="Cambria" pitchFamily="34" charset="-120"/>
+              </a:rPr>
+              <a:t>Friend A</a:t>
+            </a:r>
+            <a:endParaRPr lang="en-US" sz="1500" dirty="0"/>
+          </a:p>
+        </p:txBody>
+      </p:sp>
+      <p:sp>
+        <p:nvSpPr>
+          <p:cNvPr id="9" name="Text 7"/>
+          <p:cNvSpPr/>
+          <p:nvPr/>
+        </p:nvSpPr>
+        <p:spPr>
+          <a:xfrm>
+            <a:off x="8412480" y="2404872"/>
+            <a:ext cx="2743200" cy="274320"/>
+          </a:xfrm>
+          <a:prstGeom prst="rect">
+            <a:avLst/>
+          </a:prstGeom>
+          <a:noFill/>
+          <a:ln/>
+        </p:spPr>
+        <p:txBody>
+          <a:bodyPr wrap="square" lIns="0" tIns="0" rIns="0" bIns="0" rtlCol="0" anchor="ctr"/>
+          <a:lstStyle/>
+          <a:p>
+            <a:pPr indent="0" marL="0">
+              <a:buNone/>
+            </a:pPr>
+            <a:r>
+              <a:rPr lang="en-US" sz="1150" dirty="0">
+                <a:solidFill>
+                  <a:srgbClr val="0E7C86"/>
+                </a:solidFill>
+                <a:latin typeface="Calibri" pitchFamily="34" charset="0"/>
+                <a:ea typeface="Calibri" pitchFamily="34" charset="-122"/>
+                <a:cs typeface="Calibri" pitchFamily="34" charset="-120"/>
+              </a:rPr>
+              <a:t>session open</a:t>
+            </a:r>
+            <a:endParaRPr lang="en-US" sz="1150" dirty="0"/>
+          </a:p>
+        </p:txBody>
+      </p:sp>
+      <p:sp>
+        <p:nvSpPr>
+          <p:cNvPr id="10" name="Shape 8"/>
+          <p:cNvSpPr/>
+          <p:nvPr/>
+        </p:nvSpPr>
+        <p:spPr>
+          <a:xfrm flipV="1">
+            <a:off x="3337560" y="2400300"/>
+            <a:ext cx="4937760" cy="982980"/>
+          </a:xfrm>
+          <a:prstGeom prst="line">
+            <a:avLst/>
+          </a:prstGeom>
+          <a:noFill/>
+          <a:ln w="17780">
+            <a:solidFill>
+              <a:srgbClr val="0E7C86"/>
+            </a:solidFill>
+            <a:prstDash val="solid"/>
+            <a:headEnd type="triangle"/>
+          </a:ln>
+        </p:spPr>
+      </p:sp>
+      <p:sp>
+        <p:nvSpPr>
+          <p:cNvPr id="11" name="Shape 9"/>
+          <p:cNvSpPr/>
+          <p:nvPr/>
+        </p:nvSpPr>
+        <p:spPr>
+          <a:xfrm>
+            <a:off x="8275320" y="3063240"/>
+            <a:ext cx="3017520" cy="868680"/>
+          </a:xfrm>
+          <a:prstGeom prst="roundRect">
+            <a:avLst>
+              <a:gd name="adj" fmla="val 6316"/>
+            </a:avLst>
+          </a:prstGeom>
+          <a:solidFill>
+            <a:srgbClr val="EEF3F4"/>
+          </a:solidFill>
+          <a:ln w="16510">
+            <a:solidFill>
+              <a:srgbClr val="0E7C86"/>
+            </a:solidFill>
+            <a:prstDash val="solid"/>
+          </a:ln>
+        </p:spPr>
+      </p:sp>
+      <p:sp>
+        <p:nvSpPr>
+          <p:cNvPr id="12" name="Text 10"/>
+          <p:cNvSpPr/>
+          <p:nvPr/>
+        </p:nvSpPr>
+        <p:spPr>
+          <a:xfrm>
+            <a:off x="8412480" y="3191256"/>
+            <a:ext cx="2743200" cy="292608"/>
+          </a:xfrm>
+          <a:prstGeom prst="rect">
+            <a:avLst/>
+          </a:prstGeom>
+          <a:noFill/>
+          <a:ln/>
+        </p:spPr>
+        <p:txBody>
+          <a:bodyPr wrap="square" lIns="0" tIns="0" rIns="0" bIns="0" rtlCol="0" anchor="ctr"/>
+          <a:lstStyle/>
+          <a:p>
+            <a:pPr indent="0" marL="0">
+              <a:buNone/>
+            </a:pPr>
+            <a:r>
+              <a:rPr lang="en-US" sz="1500" b="1" dirty="0">
+                <a:solidFill>
+                  <a:srgbClr val="16202A"/>
+                </a:solidFill>
+                <a:latin typeface="Cambria" pitchFamily="34" charset="0"/>
+                <a:ea typeface="Cambria" pitchFamily="34" charset="-122"/>
+                <a:cs typeface="Cambria" pitchFamily="34" charset="-120"/>
+              </a:rPr>
+              <a:t>Friend B</a:t>
+            </a:r>
+            <a:endParaRPr lang="en-US" sz="1500" dirty="0"/>
+          </a:p>
+        </p:txBody>
+      </p:sp>
+      <p:sp>
+        <p:nvSpPr>
+          <p:cNvPr id="13" name="Text 11"/>
+          <p:cNvSpPr/>
+          <p:nvPr/>
+        </p:nvSpPr>
+        <p:spPr>
+          <a:xfrm>
+            <a:off x="8412480" y="3502152"/>
+            <a:ext cx="2743200" cy="274320"/>
+          </a:xfrm>
+          <a:prstGeom prst="rect">
+            <a:avLst/>
+          </a:prstGeom>
+          <a:noFill/>
+          <a:ln/>
+        </p:spPr>
+        <p:txBody>
+          <a:bodyPr wrap="square" lIns="0" tIns="0" rIns="0" bIns="0" rtlCol="0" anchor="ctr"/>
+          <a:lstStyle/>
+          <a:p>
+            <a:pPr indent="0" marL="0">
+              <a:buNone/>
+            </a:pPr>
+            <a:r>
+              <a:rPr lang="en-US" sz="1150" dirty="0">
+                <a:solidFill>
+                  <a:srgbClr val="0E7C86"/>
+                </a:solidFill>
+                <a:latin typeface="Calibri" pitchFamily="34" charset="0"/>
+                <a:ea typeface="Calibri" pitchFamily="34" charset="-122"/>
+                <a:cs typeface="Calibri" pitchFamily="34" charset="-120"/>
+              </a:rPr>
+              <a:t>new source port</a:t>
+            </a:r>
+            <a:endParaRPr lang="en-US" sz="1150" dirty="0"/>
+          </a:p>
+        </p:txBody>
+      </p:sp>
+      <p:sp>
+        <p:nvSpPr>
+          <p:cNvPr id="14" name="Shape 12"/>
+          <p:cNvSpPr/>
+          <p:nvPr/>
+        </p:nvSpPr>
+        <p:spPr>
+          <a:xfrm>
+            <a:off x="3337560" y="3383280"/>
+            <a:ext cx="4937760" cy="114300"/>
+          </a:xfrm>
+          <a:prstGeom prst="line">
+            <a:avLst/>
+          </a:prstGeom>
+          <a:noFill/>
+          <a:ln w="17780">
+            <a:solidFill>
+              <a:srgbClr val="0E7C86"/>
+            </a:solidFill>
+            <a:prstDash val="solid"/>
+            <a:headEnd type="triangle"/>
+          </a:ln>
+        </p:spPr>
+      </p:sp>
+      <p:sp>
+        <p:nvSpPr>
+          <p:cNvPr id="15" name="Shape 13"/>
+          <p:cNvSpPr/>
+          <p:nvPr/>
+        </p:nvSpPr>
+        <p:spPr>
+          <a:xfrm>
+            <a:off x="8275320" y="4160520"/>
+            <a:ext cx="3017520" cy="868680"/>
+          </a:xfrm>
+          <a:prstGeom prst="roundRect">
+            <a:avLst>
+              <a:gd name="adj" fmla="val 6316"/>
+            </a:avLst>
+          </a:prstGeom>
+          <a:solidFill>
+            <a:srgbClr val="EEF3F4"/>
+          </a:solidFill>
+          <a:ln w="16510">
             <a:solidFill>
               <a:srgbClr val="C25E28"/>
             </a:solidFill>
@@ -4896,30 +5189,30 @@
       </p:sp>
       <p:sp>
         <p:nvSpPr>
-          <p:cNvPr id="6" name="Text 4"/>
-          <p:cNvSpPr/>
-          <p:nvPr/>
-        </p:nvSpPr>
-        <p:spPr>
-          <a:xfrm>
-            <a:off x="1051560" y="2880360"/>
-            <a:ext cx="4480560" cy="365760"/>
-          </a:xfrm>
-          <a:prstGeom prst="rect">
-            <a:avLst/>
-          </a:prstGeom>
-          <a:noFill/>
-          <a:ln/>
-        </p:spPr>
-        <p:txBody>
-          <a:bodyPr wrap="square" lIns="0" tIns="0" rIns="0" bIns="0" rtlCol="0" anchor="ctr"/>
-          <a:lstStyle/>
-          <a:p>
-            <a:pPr indent="0" marL="0">
-              <a:buNone/>
-            </a:pPr>
-            <a:r>
-              <a:rPr lang="en-US" sz="2000" b="1" dirty="0">
+          <p:cNvPr id="16" name="Text 14"/>
+          <p:cNvSpPr/>
+          <p:nvPr/>
+        </p:nvSpPr>
+        <p:spPr>
+          <a:xfrm>
+            <a:off x="8412480" y="4288536"/>
+            <a:ext cx="2743200" cy="292608"/>
+          </a:xfrm>
+          <a:prstGeom prst="rect">
+            <a:avLst/>
+          </a:prstGeom>
+          <a:noFill/>
+          <a:ln/>
+        </p:spPr>
+        <p:txBody>
+          <a:bodyPr wrap="square" lIns="0" tIns="0" rIns="0" bIns="0" rtlCol="0" anchor="ctr"/>
+          <a:lstStyle/>
+          <a:p>
+            <a:pPr indent="0" marL="0">
+              <a:buNone/>
+            </a:pPr>
+            <a:r>
+              <a:rPr lang="en-US" sz="1500" b="1" dirty="0">
                 <a:solidFill>
                   <a:srgbClr val="16202A"/>
                 </a:solidFill>
@@ -4927,241 +5220,124 @@
                 <a:ea typeface="Cambria" pitchFamily="34" charset="-122"/>
                 <a:cs typeface="Cambria" pitchFamily="34" charset="-120"/>
               </a:rPr>
-              <a:t>Contamination</a:t>
-            </a:r>
-            <a:endParaRPr lang="en-US" sz="2000" dirty="0"/>
-          </a:p>
-        </p:txBody>
-      </p:sp>
-      <p:sp>
-        <p:nvSpPr>
-          <p:cNvPr id="7" name="Shape 5"/>
-          <p:cNvSpPr/>
-          <p:nvPr/>
-        </p:nvSpPr>
-        <p:spPr>
-          <a:xfrm>
-            <a:off x="1051560" y="3456432"/>
-            <a:ext cx="118872" cy="118872"/>
-          </a:xfrm>
-          <a:prstGeom prst="ellipse">
-            <a:avLst/>
-          </a:prstGeom>
-          <a:solidFill>
-            <a:srgbClr val="C25E28"/>
-          </a:solidFill>
-          <a:ln w="12700">
+              <a:t>Friend C</a:t>
+            </a:r>
+            <a:endParaRPr lang="en-US" sz="1500" dirty="0"/>
+          </a:p>
+        </p:txBody>
+      </p:sp>
+      <p:sp>
+        <p:nvSpPr>
+          <p:cNvPr id="17" name="Text 15"/>
+          <p:cNvSpPr/>
+          <p:nvPr/>
+        </p:nvSpPr>
+        <p:spPr>
+          <a:xfrm>
+            <a:off x="8412480" y="4599432"/>
+            <a:ext cx="2743200" cy="274320"/>
+          </a:xfrm>
+          <a:prstGeom prst="rect">
+            <a:avLst/>
+          </a:prstGeom>
+          <a:noFill/>
+          <a:ln/>
+        </p:spPr>
+        <p:txBody>
+          <a:bodyPr wrap="square" lIns="0" tIns="0" rIns="0" bIns="0" rtlCol="0" anchor="ctr"/>
+          <a:lstStyle/>
+          <a:p>
+            <a:pPr indent="0" marL="0">
+              <a:buNone/>
+            </a:pPr>
+            <a:r>
+              <a:rPr lang="en-US" sz="1150" dirty="0">
+                <a:solidFill>
+                  <a:srgbClr val="C25E28"/>
+                </a:solidFill>
+                <a:latin typeface="Calibri" pitchFamily="34" charset="0"/>
+                <a:ea typeface="Calibri" pitchFamily="34" charset="-122"/>
+                <a:cs typeface="Calibri" pitchFamily="34" charset="-120"/>
+              </a:rPr>
+              <a:t>never contacted</a:t>
+            </a:r>
+            <a:endParaRPr lang="en-US" sz="1150" dirty="0"/>
+          </a:p>
+        </p:txBody>
+      </p:sp>
+      <p:sp>
+        <p:nvSpPr>
+          <p:cNvPr id="18" name="Shape 16"/>
+          <p:cNvSpPr/>
+          <p:nvPr/>
+        </p:nvSpPr>
+        <p:spPr>
+          <a:xfrm>
+            <a:off x="3337560" y="3383280"/>
+            <a:ext cx="4937760" cy="1211580"/>
+          </a:xfrm>
+          <a:prstGeom prst="line">
+            <a:avLst/>
+          </a:prstGeom>
+          <a:noFill/>
+          <a:ln w="17780">
             <a:solidFill>
               <a:srgbClr val="C25E28"/>
             </a:solidFill>
             <a:prstDash val="solid"/>
+            <a:headEnd type="triangle"/>
           </a:ln>
         </p:spPr>
       </p:sp>
       <p:sp>
         <p:nvSpPr>
-          <p:cNvPr id="8" name="Text 6"/>
-          <p:cNvSpPr/>
-          <p:nvPr/>
-        </p:nvSpPr>
-        <p:spPr>
-          <a:xfrm>
-            <a:off x="1371600" y="3337560"/>
-            <a:ext cx="4160520" cy="384048"/>
-          </a:xfrm>
-          <a:prstGeom prst="rect">
-            <a:avLst/>
-          </a:prstGeom>
-          <a:noFill/>
-          <a:ln/>
-        </p:spPr>
-        <p:txBody>
-          <a:bodyPr wrap="square" lIns="0" tIns="0" rIns="0" bIns="0" rtlCol="0" anchor="ctr"/>
-          <a:lstStyle/>
-          <a:p>
-            <a:pPr indent="0" marL="0">
-              <a:buNone/>
-            </a:pPr>
-            <a:r>
-              <a:rPr lang="en-US" sz="1350" dirty="0">
-                <a:solidFill>
-                  <a:srgbClr val="3E4C57"/>
+          <p:cNvPr id="19" name="Text 17"/>
+          <p:cNvSpPr/>
+          <p:nvPr/>
+        </p:nvSpPr>
+        <p:spPr>
+          <a:xfrm>
+            <a:off x="1051560" y="4069080"/>
+            <a:ext cx="2286000" cy="274320"/>
+          </a:xfrm>
+          <a:prstGeom prst="rect">
+            <a:avLst/>
+          </a:prstGeom>
+          <a:noFill/>
+          <a:ln/>
+        </p:spPr>
+        <p:txBody>
+          <a:bodyPr wrap="square" lIns="0" tIns="0" rIns="0" bIns="0" rtlCol="0" anchor="ctr"/>
+          <a:lstStyle/>
+          <a:p>
+            <a:pPr algn="ctr" indent="0" marL="0">
+              <a:buNone/>
+            </a:pPr>
+            <a:r>
+              <a:rPr lang="en-US" sz="1150" dirty="0">
+                <a:solidFill>
+                  <a:srgbClr val="6E7F8B"/>
                 </a:solidFill>
                 <a:latin typeface="Calibri" pitchFamily="34" charset="0"/>
                 <a:ea typeface="Calibri" pitchFamily="34" charset="-122"/>
                 <a:cs typeface="Calibri" pitchFamily="34" charset="-120"/>
               </a:rPr>
-              <a:t>Witnesses are the peers we already transmit to.</a:t>
-            </a:r>
-            <a:endParaRPr lang="en-US" sz="1350" dirty="0"/>
-          </a:p>
-        </p:txBody>
-      </p:sp>
-      <p:sp>
-        <p:nvSpPr>
-          <p:cNvPr id="9" name="Shape 7"/>
-          <p:cNvSpPr/>
-          <p:nvPr/>
-        </p:nvSpPr>
-        <p:spPr>
-          <a:xfrm>
-            <a:off x="1051560" y="3840480"/>
+              <a:t>each dial-back carries the nonce</a:t>
+            </a:r>
+            <a:endParaRPr lang="en-US" sz="1150" dirty="0"/>
+          </a:p>
+        </p:txBody>
+      </p:sp>
+      <p:sp>
+        <p:nvSpPr>
+          <p:cNvPr id="20" name="Shape 18"/>
+          <p:cNvSpPr/>
+          <p:nvPr/>
+        </p:nvSpPr>
+        <p:spPr>
+          <a:xfrm>
+            <a:off x="685800" y="5376672"/>
             <a:ext cx="118872" cy="118872"/>
-          </a:xfrm>
-          <a:prstGeom prst="ellipse">
-            <a:avLst/>
-          </a:prstGeom>
-          <a:solidFill>
-            <a:srgbClr val="C25E28"/>
-          </a:solidFill>
-          <a:ln w="12700">
-            <a:solidFill>
-              <a:srgbClr val="C25E28"/>
-            </a:solidFill>
-            <a:prstDash val="solid"/>
-          </a:ln>
-        </p:spPr>
-      </p:sp>
-      <p:sp>
-        <p:nvSpPr>
-          <p:cNvPr id="10" name="Text 8"/>
-          <p:cNvSpPr/>
-          <p:nvPr/>
-        </p:nvSpPr>
-        <p:spPr>
-          <a:xfrm>
-            <a:off x="1371600" y="3721608"/>
-            <a:ext cx="4160520" cy="384048"/>
-          </a:xfrm>
-          <a:prstGeom prst="rect">
-            <a:avLst/>
-          </a:prstGeom>
-          <a:noFill/>
-          <a:ln/>
-        </p:spPr>
-        <p:txBody>
-          <a:bodyPr wrap="square" lIns="0" tIns="0" rIns="0" bIns="0" rtlCol="0" anchor="ctr"/>
-          <a:lstStyle/>
-          <a:p>
-            <a:pPr indent="0" marL="0">
-              <a:buNone/>
-            </a:pPr>
-            <a:r>
-              <a:rPr lang="en-US" sz="1350" dirty="0">
-                <a:solidFill>
-                  <a:srgbClr val="3E4C57"/>
-                </a:solidFill>
-                <a:latin typeface="Calibri" pitchFamily="34" charset="0"/>
-                <a:ea typeface="Calibri" pitchFamily="34" charset="-122"/>
-                <a:cs typeface="Calibri" pitchFamily="34" charset="-120"/>
-              </a:rPr>
-              <a:t>It measures our own mapping, not the NAT rule.</a:t>
-            </a:r>
-            <a:endParaRPr lang="en-US" sz="1350" dirty="0"/>
-          </a:p>
-        </p:txBody>
-      </p:sp>
-      <p:sp>
-        <p:nvSpPr>
-          <p:cNvPr id="11" name="Shape 9"/>
-          <p:cNvSpPr/>
-          <p:nvPr/>
-        </p:nvSpPr>
-        <p:spPr>
-          <a:xfrm>
-            <a:off x="1051560" y="4224528"/>
-            <a:ext cx="118872" cy="118872"/>
-          </a:xfrm>
-          <a:prstGeom prst="ellipse">
-            <a:avLst/>
-          </a:prstGeom>
-          <a:solidFill>
-            <a:srgbClr val="C25E28"/>
-          </a:solidFill>
-          <a:ln w="12700">
-            <a:solidFill>
-              <a:srgbClr val="C25E28"/>
-            </a:solidFill>
-            <a:prstDash val="solid"/>
-          </a:ln>
-        </p:spPr>
-      </p:sp>
-      <p:sp>
-        <p:nvSpPr>
-          <p:cNvPr id="12" name="Text 10"/>
-          <p:cNvSpPr/>
-          <p:nvPr/>
-        </p:nvSpPr>
-        <p:spPr>
-          <a:xfrm>
-            <a:off x="1371600" y="4105656"/>
-            <a:ext cx="4160520" cy="384048"/>
-          </a:xfrm>
-          <a:prstGeom prst="rect">
-            <a:avLst/>
-          </a:prstGeom>
-          <a:noFill/>
-          <a:ln/>
-        </p:spPr>
-        <p:txBody>
-          <a:bodyPr wrap="square" lIns="0" tIns="0" rIns="0" bIns="0" rtlCol="0" anchor="ctr"/>
-          <a:lstStyle/>
-          <a:p>
-            <a:pPr indent="0" marL="0">
-              <a:buNone/>
-            </a:pPr>
-            <a:r>
-              <a:rPr lang="en-US" sz="1350" dirty="0">
-                <a:solidFill>
-                  <a:srgbClr val="3E4C57"/>
-                </a:solidFill>
-                <a:latin typeface="Calibri" pitchFamily="34" charset="0"/>
-                <a:ea typeface="Calibri" pitchFamily="34" charset="-122"/>
-                <a:cs typeface="Calibri" pitchFamily="34" charset="-120"/>
-              </a:rPr>
-              <a:t>Guard: a per-test send history discards contacted sources.</a:t>
-            </a:r>
-            <a:endParaRPr lang="en-US" sz="1350" dirty="0"/>
-          </a:p>
-        </p:txBody>
-      </p:sp>
-      <p:sp>
-        <p:nvSpPr>
-          <p:cNvPr id="13" name="Shape 11"/>
-          <p:cNvSpPr/>
-          <p:nvPr/>
-        </p:nvSpPr>
-        <p:spPr>
-          <a:xfrm>
-            <a:off x="6263640" y="2103120"/>
-            <a:ext cx="5212080" cy="2651760"/>
-          </a:xfrm>
-          <a:prstGeom prst="roundRect">
-            <a:avLst>
-              <a:gd name="adj" fmla="val 2069"/>
-            </a:avLst>
-          </a:prstGeom>
-          <a:solidFill>
-            <a:srgbClr val="EEF3F4"/>
-          </a:solidFill>
-          <a:ln w="6350">
-            <a:solidFill>
-              <a:srgbClr val="EEF3F4"/>
-            </a:solidFill>
-            <a:prstDash val="solid"/>
-          </a:ln>
-        </p:spPr>
-      </p:sp>
-      <p:sp>
-        <p:nvSpPr>
-          <p:cNvPr id="14" name="Shape 12"/>
-          <p:cNvSpPr/>
-          <p:nvPr/>
-        </p:nvSpPr>
-        <p:spPr>
-          <a:xfrm>
-            <a:off x="6629400" y="2377440"/>
-            <a:ext cx="365760" cy="365760"/>
           </a:xfrm>
           <a:prstGeom prst="ellipse">
             <a:avLst/>
@@ -5179,52 +5355,52 @@
       </p:sp>
       <p:sp>
         <p:nvSpPr>
-          <p:cNvPr id="15" name="Text 13"/>
-          <p:cNvSpPr/>
-          <p:nvPr/>
-        </p:nvSpPr>
-        <p:spPr>
-          <a:xfrm>
-            <a:off x="6629400" y="2880360"/>
-            <a:ext cx="4480560" cy="365760"/>
-          </a:xfrm>
-          <a:prstGeom prst="rect">
-            <a:avLst/>
-          </a:prstGeom>
-          <a:noFill/>
-          <a:ln/>
-        </p:spPr>
-        <p:txBody>
-          <a:bodyPr wrap="square" lIns="0" tIns="0" rIns="0" bIns="0" rtlCol="0" anchor="ctr"/>
-          <a:lstStyle/>
-          <a:p>
-            <a:pPr indent="0" marL="0">
-              <a:buNone/>
-            </a:pPr>
-            <a:r>
-              <a:rPr lang="en-US" sz="2000" b="1" dirty="0">
-                <a:solidFill>
-                  <a:srgbClr val="16202A"/>
-                </a:solidFill>
-                <a:latin typeface="Cambria" pitchFamily="34" charset="0"/>
-                <a:ea typeface="Cambria" pitchFamily="34" charset="-122"/>
-                <a:cs typeface="Cambria" pitchFamily="34" charset="-120"/>
-              </a:rPr>
-              <a:t>Dishonest witnesses</a:t>
-            </a:r>
-            <a:endParaRPr lang="en-US" sz="2000" dirty="0"/>
-          </a:p>
-        </p:txBody>
-      </p:sp>
-      <p:sp>
-        <p:nvSpPr>
-          <p:cNvPr id="16" name="Shape 14"/>
-          <p:cNvSpPr/>
-          <p:nvPr/>
-        </p:nvSpPr>
-        <p:spPr>
-          <a:xfrm>
-            <a:off x="6629400" y="3456432"/>
+          <p:cNvPr id="21" name="Text 19"/>
+          <p:cNvSpPr/>
+          <p:nvPr/>
+        </p:nvSpPr>
+        <p:spPr>
+          <a:xfrm>
+            <a:off x="1005840" y="5257800"/>
+            <a:ext cx="10469880" cy="384048"/>
+          </a:xfrm>
+          <a:prstGeom prst="rect">
+            <a:avLst/>
+          </a:prstGeom>
+          <a:noFill/>
+          <a:ln/>
+        </p:spPr>
+        <p:txBody>
+          <a:bodyPr wrap="square" lIns="0" tIns="0" rIns="0" bIns="0" rtlCol="0" anchor="ctr"/>
+          <a:lstStyle/>
+          <a:p>
+            <a:pPr indent="0" marL="0">
+              <a:buNone/>
+            </a:pPr>
+            <a:r>
+              <a:rPr lang="en-US" sz="1650" dirty="0">
+                <a:solidFill>
+                  <a:srgbClr val="3E4C57"/>
+                </a:solidFill>
+                <a:latin typeface="Calibri" pitchFamily="34" charset="0"/>
+                <a:ea typeface="Calibri" pitchFamily="34" charset="-122"/>
+                <a:cs typeface="Calibri" pitchFamily="34" charset="-120"/>
+              </a:rPr>
+              <a:t>Only friends. The probe asks each of them directly.</a:t>
+            </a:r>
+            <a:endParaRPr lang="en-US" sz="1650" dirty="0"/>
+          </a:p>
+        </p:txBody>
+      </p:sp>
+      <p:sp>
+        <p:nvSpPr>
+          <p:cNvPr id="22" name="Shape 20"/>
+          <p:cNvSpPr/>
+          <p:nvPr/>
+        </p:nvSpPr>
+        <p:spPr>
+          <a:xfrm>
+            <a:off x="685800" y="5779008"/>
             <a:ext cx="118872" cy="118872"/>
           </a:xfrm>
           <a:prstGeom prst="ellipse">
@@ -5243,30 +5419,30 @@
       </p:sp>
       <p:sp>
         <p:nvSpPr>
-          <p:cNvPr id="17" name="Text 15"/>
-          <p:cNvSpPr/>
-          <p:nvPr/>
-        </p:nvSpPr>
-        <p:spPr>
-          <a:xfrm>
-            <a:off x="6949440" y="3337560"/>
-            <a:ext cx="4160520" cy="384048"/>
-          </a:xfrm>
-          <a:prstGeom prst="rect">
-            <a:avLst/>
-          </a:prstGeom>
-          <a:noFill/>
-          <a:ln/>
-        </p:spPr>
-        <p:txBody>
-          <a:bodyPr wrap="square" lIns="0" tIns="0" rIns="0" bIns="0" rtlCol="0" anchor="ctr"/>
-          <a:lstStyle/>
-          <a:p>
-            <a:pPr indent="0" marL="0">
-              <a:buNone/>
-            </a:pPr>
-            <a:r>
-              <a:rPr lang="en-US" sz="1350" dirty="0">
+          <p:cNvPr id="23" name="Text 21"/>
+          <p:cNvSpPr/>
+          <p:nvPr/>
+        </p:nvSpPr>
+        <p:spPr>
+          <a:xfrm>
+            <a:off x="1005840" y="5660136"/>
+            <a:ext cx="10469880" cy="384048"/>
+          </a:xfrm>
+          <a:prstGeom prst="rect">
+            <a:avLst/>
+          </a:prstGeom>
+          <a:noFill/>
+          <a:ln/>
+        </p:spPr>
+        <p:txBody>
+          <a:bodyPr wrap="square" lIns="0" tIns="0" rIns="0" bIns="0" rtlCol="0" anchor="ctr"/>
+          <a:lstStyle/>
+          <a:p>
+            <a:pPr indent="0" marL="0">
+              <a:buNone/>
+            </a:pPr>
+            <a:r>
+              <a:rPr lang="en-US" sz="1650" dirty="0">
                 <a:solidFill>
                   <a:srgbClr val="3E4C57"/>
                 </a:solidFill>
@@ -5274,21 +5450,21 @@
                 <a:ea typeface="Calibri" pitchFamily="34" charset="-122"/>
                 <a:cs typeface="Calibri" pitchFamily="34" charset="-120"/>
               </a:rPr>
-              <a:t>A nonce cannot be forged, but a failure can be fabricated.</a:t>
-            </a:r>
-            <a:endParaRPr lang="en-US" sz="1350" dirty="0"/>
-          </a:p>
-        </p:txBody>
-      </p:sp>
-      <p:sp>
-        <p:nvSpPr>
-          <p:cNvPr id="18" name="Shape 16"/>
-          <p:cNvSpPr/>
-          <p:nvPr/>
-        </p:nvSpPr>
-        <p:spPr>
-          <a:xfrm>
-            <a:off x="6629400" y="3840480"/>
+              <a:t>They dial back from different addresses and ports.</a:t>
+            </a:r>
+            <a:endParaRPr lang="en-US" sz="1650" dirty="0"/>
+          </a:p>
+        </p:txBody>
+      </p:sp>
+      <p:sp>
+        <p:nvSpPr>
+          <p:cNvPr id="24" name="Shape 22"/>
+          <p:cNvSpPr/>
+          <p:nvPr/>
+        </p:nvSpPr>
+        <p:spPr>
+          <a:xfrm>
+            <a:off x="685800" y="6181344"/>
             <a:ext cx="118872" cy="118872"/>
           </a:xfrm>
           <a:prstGeom prst="ellipse">
@@ -5307,30 +5483,30 @@
       </p:sp>
       <p:sp>
         <p:nvSpPr>
-          <p:cNvPr id="19" name="Text 17"/>
-          <p:cNvSpPr/>
-          <p:nvPr/>
-        </p:nvSpPr>
-        <p:spPr>
-          <a:xfrm>
-            <a:off x="6949440" y="3721608"/>
-            <a:ext cx="4160520" cy="384048"/>
-          </a:xfrm>
-          <a:prstGeom prst="rect">
-            <a:avLst/>
-          </a:prstGeom>
-          <a:noFill/>
-          <a:ln/>
-        </p:spPr>
-        <p:txBody>
-          <a:bodyPr wrap="square" lIns="0" tIns="0" rIns="0" bIns="0" rtlCol="0" anchor="ctr"/>
-          <a:lstStyle/>
-          <a:p>
-            <a:pPr indent="0" marL="0">
-              <a:buNone/>
-            </a:pPr>
-            <a:r>
-              <a:rPr lang="en-US" sz="1350" dirty="0">
+          <p:cNvPr id="25" name="Text 23"/>
+          <p:cNvSpPr/>
+          <p:nvPr/>
+        </p:nvSpPr>
+        <p:spPr>
+          <a:xfrm>
+            <a:off x="1005840" y="6062472"/>
+            <a:ext cx="10469880" cy="384048"/>
+          </a:xfrm>
+          <a:prstGeom prst="rect">
+            <a:avLst/>
+          </a:prstGeom>
+          <a:noFill/>
+          <a:ln/>
+        </p:spPr>
+        <p:txBody>
+          <a:bodyPr wrap="square" lIns="0" tIns="0" rIns="0" bIns="0" rtlCol="0" anchor="ctr"/>
+          <a:lstStyle/>
+          <a:p>
+            <a:pPr indent="0" marL="0">
+              <a:buNone/>
+            </a:pPr>
+            <a:r>
+              <a:rPr lang="en-US" sz="1650" dirty="0">
                 <a:solidFill>
                   <a:srgbClr val="3E4C57"/>
                 </a:solidFill>
@@ -5338,112 +5514,9 @@
                 <a:ea typeface="Calibri" pitchFamily="34" charset="-122"/>
                 <a:cs typeface="Calibri" pitchFamily="34" charset="-120"/>
               </a:rPr>
-              <a:t>One verified success proves reachability.</a:t>
-            </a:r>
-            <a:endParaRPr lang="en-US" sz="1350" dirty="0"/>
-          </a:p>
-        </p:txBody>
-      </p:sp>
-      <p:sp>
-        <p:nvSpPr>
-          <p:cNvPr id="20" name="Shape 18"/>
-          <p:cNvSpPr/>
-          <p:nvPr/>
-        </p:nvSpPr>
-        <p:spPr>
-          <a:xfrm>
-            <a:off x="6629400" y="4224528"/>
-            <a:ext cx="118872" cy="118872"/>
-          </a:xfrm>
-          <a:prstGeom prst="ellipse">
-            <a:avLst/>
-          </a:prstGeom>
-          <a:solidFill>
-            <a:srgbClr val="0E7C86"/>
-          </a:solidFill>
-          <a:ln w="12700">
-            <a:solidFill>
-              <a:srgbClr val="0E7C86"/>
-            </a:solidFill>
-            <a:prstDash val="solid"/>
-          </a:ln>
-        </p:spPr>
-      </p:sp>
-      <p:sp>
-        <p:nvSpPr>
-          <p:cNvPr id="21" name="Text 19"/>
-          <p:cNvSpPr/>
-          <p:nvPr/>
-        </p:nvSpPr>
-        <p:spPr>
-          <a:xfrm>
-            <a:off x="6949440" y="4105656"/>
-            <a:ext cx="4160520" cy="384048"/>
-          </a:xfrm>
-          <a:prstGeom prst="rect">
-            <a:avLst/>
-          </a:prstGeom>
-          <a:noFill/>
-          <a:ln/>
-        </p:spPr>
-        <p:txBody>
-          <a:bodyPr wrap="square" lIns="0" tIns="0" rIns="0" bIns="0" rtlCol="0" anchor="ctr"/>
-          <a:lstStyle/>
-          <a:p>
-            <a:pPr indent="0" marL="0">
-              <a:buNone/>
-            </a:pPr>
-            <a:r>
-              <a:rPr lang="en-US" sz="1350" dirty="0">
-                <a:solidFill>
-                  <a:srgbClr val="3E4C57"/>
-                </a:solidFill>
-                <a:latin typeface="Calibri" pitchFamily="34" charset="0"/>
-                <a:ea typeface="Calibri" pitchFamily="34" charset="-122"/>
-                <a:cs typeface="Calibri" pitchFamily="34" charset="-120"/>
-              </a:rPr>
-              <a:t>Unreachability needs k independent failures.</a:t>
-            </a:r>
-            <a:endParaRPr lang="en-US" sz="1350" dirty="0"/>
-          </a:p>
-        </p:txBody>
-      </p:sp>
-      <p:sp>
-        <p:nvSpPr>
-          <p:cNvPr id="22" name="Text 20"/>
-          <p:cNvSpPr/>
-          <p:nvPr/>
-        </p:nvSpPr>
-        <p:spPr>
-          <a:xfrm>
-            <a:off x="685800" y="5120640"/>
-            <a:ext cx="10789920" cy="365760"/>
-          </a:xfrm>
-          <a:prstGeom prst="rect">
-            <a:avLst/>
-          </a:prstGeom>
-          <a:noFill/>
-          <a:ln/>
-        </p:spPr>
-        <p:txBody>
-          <a:bodyPr wrap="square" lIns="0" tIns="0" rIns="0" bIns="0" rtlCol="0" anchor="ctr"/>
-          <a:lstStyle/>
-          <a:p>
-            <a:pPr indent="0" marL="0">
-              <a:buNone/>
-            </a:pPr>
-            <a:r>
-              <a:rPr lang="en-US" sz="1500" i="1" dirty="0">
-                <a:solidFill>
-                  <a:srgbClr val="0A5A62"/>
-                </a:solidFill>
-                <a:latin typeface="Calibri" pitchFamily="34" charset="0"/>
-                <a:ea typeface="Calibri" pitchFamily="34" charset="-122"/>
-                <a:cs typeface="Calibri" pitchFamily="34" charset="-120"/>
-              </a:rPr>
-              <a:t>Both are studied on the bench, where we operate every witness and know who lied.</a:t>
-            </a:r>
-            <a:endParaRPr lang="en-US" sz="1500" dirty="0"/>
+              <a:t>A nonce in each reply makes a fabricated dial-back impossible.</a:t>
+            </a:r>
+            <a:endParaRPr lang="en-US" sz="1650" dirty="0"/>
           </a:p>
         </p:txBody>
       </p:sp>
@@ -5505,7 +5578,7 @@
                 <a:ea typeface="Calibri" pitchFamily="34" charset="-122"/>
                 <a:cs typeface="Calibri" pitchFamily="34" charset="-120"/>
               </a:rPr>
-              <a:t>WHAT IS RECORDED</a:t>
+              <a:t>WHAT COULD INVALIDATE THE RESULT</a:t>
             </a:r>
             <a:endParaRPr lang="en-US" sz="1100" dirty="0"/>
           </a:p>
@@ -5544,7 +5617,7 @@
                 <a:ea typeface="Cambria" pitchFamily="34" charset="-122"/>
                 <a:cs typeface="Cambria" pitchFamily="34" charset="-120"/>
               </a:rPr>
-              <a:t>The measurand</a:t>
+              <a:t>Two validity threats</a:t>
             </a:r>
             <a:endParaRPr lang="en-US" sz="3600" dirty="0"/>
           </a:p>
@@ -5558,12 +5631,12 @@
         </p:nvSpPr>
         <p:spPr>
           <a:xfrm>
-            <a:off x="685800" y="2194560"/>
-            <a:ext cx="2468880" cy="1371600"/>
+            <a:off x="685800" y="2103120"/>
+            <a:ext cx="5212080" cy="2651760"/>
           </a:xfrm>
           <a:prstGeom prst="roundRect">
             <a:avLst>
-              <a:gd name="adj" fmla="val 4000"/>
+              <a:gd name="adj" fmla="val 2069"/>
             </a:avLst>
           </a:prstGeom>
           <a:solidFill>
@@ -5579,74 +5652,274 @@
       </p:sp>
       <p:sp>
         <p:nvSpPr>
-          <p:cNvPr id="5" name="Text 3"/>
-          <p:cNvSpPr/>
-          <p:nvPr/>
-        </p:nvSpPr>
-        <p:spPr>
-          <a:xfrm>
-            <a:off x="777240" y="2194560"/>
-            <a:ext cx="2286000" cy="1371600"/>
-          </a:xfrm>
-          <a:prstGeom prst="rect">
-            <a:avLst/>
-          </a:prstGeom>
-          <a:noFill/>
-          <a:ln/>
-        </p:spPr>
-        <p:txBody>
-          <a:bodyPr wrap="square" lIns="0" tIns="0" rIns="0" bIns="0" rtlCol="0" anchor="ctr"/>
-          <a:lstStyle/>
-          <a:p>
-            <a:pPr algn="ctr" indent="0" marL="0">
-              <a:buNone/>
-            </a:pPr>
-            <a:r>
-              <a:rPr lang="en-US" sz="1700" b="1" dirty="0">
-                <a:solidFill>
-                  <a:srgbClr val="0A5A62"/>
+          <p:cNvPr id="5" name="Shape 3"/>
+          <p:cNvSpPr/>
+          <p:nvPr/>
+        </p:nvSpPr>
+        <p:spPr>
+          <a:xfrm>
+            <a:off x="1051560" y="2377440"/>
+            <a:ext cx="365760" cy="365760"/>
+          </a:xfrm>
+          <a:prstGeom prst="ellipse">
+            <a:avLst/>
+          </a:prstGeom>
+          <a:solidFill>
+            <a:srgbClr val="C25E28"/>
+          </a:solidFill>
+          <a:ln w="12700">
+            <a:solidFill>
+              <a:srgbClr val="C25E28"/>
+            </a:solidFill>
+            <a:prstDash val="solid"/>
+          </a:ln>
+        </p:spPr>
+      </p:sp>
+      <p:sp>
+        <p:nvSpPr>
+          <p:cNvPr id="6" name="Text 4"/>
+          <p:cNvSpPr/>
+          <p:nvPr/>
+        </p:nvSpPr>
+        <p:spPr>
+          <a:xfrm>
+            <a:off x="1051560" y="2880360"/>
+            <a:ext cx="4480560" cy="365760"/>
+          </a:xfrm>
+          <a:prstGeom prst="rect">
+            <a:avLst/>
+          </a:prstGeom>
+          <a:noFill/>
+          <a:ln/>
+        </p:spPr>
+        <p:txBody>
+          <a:bodyPr wrap="square" lIns="0" tIns="0" rIns="0" bIns="0" rtlCol="0" anchor="ctr"/>
+          <a:lstStyle/>
+          <a:p>
+            <a:pPr indent="0" marL="0">
+              <a:buNone/>
+            </a:pPr>
+            <a:r>
+              <a:rPr lang="en-US" sz="2000" b="1" dirty="0">
+                <a:solidFill>
+                  <a:srgbClr val="16202A"/>
                 </a:solidFill>
                 <a:latin typeface="Cambria" pitchFamily="34" charset="0"/>
                 <a:ea typeface="Cambria" pitchFamily="34" charset="-122"/>
                 <a:cs typeface="Cambria" pitchFamily="34" charset="-120"/>
               </a:rPr>
-              <a:t>Mapping</a:t>
-            </a:r>
-            <a:endParaRPr lang="en-US" sz="1700" dirty="0"/>
-          </a:p>
-          <a:p>
-            <a:pPr algn="ctr" indent="0" marL="0">
-              <a:buNone/>
-            </a:pPr>
-            <a:r>
-              <a:rPr lang="en-US" sz="1700" b="1" dirty="0">
-                <a:solidFill>
-                  <a:srgbClr val="0A5A62"/>
-                </a:solidFill>
-                <a:latin typeface="Cambria" pitchFamily="34" charset="0"/>
-                <a:ea typeface="Cambria" pitchFamily="34" charset="-122"/>
-                <a:cs typeface="Cambria" pitchFamily="34" charset="-120"/>
-              </a:rPr>
-              <a:t>behavior</a:t>
-            </a:r>
-            <a:endParaRPr lang="en-US" sz="1700" dirty="0"/>
-          </a:p>
-        </p:txBody>
-      </p:sp>
-      <p:sp>
-        <p:nvSpPr>
-          <p:cNvPr id="6" name="Shape 4"/>
-          <p:cNvSpPr/>
-          <p:nvPr/>
-        </p:nvSpPr>
-        <p:spPr>
-          <a:xfrm>
-            <a:off x="3474720" y="2194560"/>
-            <a:ext cx="2468880" cy="1371600"/>
+              <a:t>Contamination</a:t>
+            </a:r>
+            <a:endParaRPr lang="en-US" sz="2000" dirty="0"/>
+          </a:p>
+        </p:txBody>
+      </p:sp>
+      <p:sp>
+        <p:nvSpPr>
+          <p:cNvPr id="7" name="Shape 5"/>
+          <p:cNvSpPr/>
+          <p:nvPr/>
+        </p:nvSpPr>
+        <p:spPr>
+          <a:xfrm>
+            <a:off x="1051560" y="3456432"/>
+            <a:ext cx="118872" cy="118872"/>
+          </a:xfrm>
+          <a:prstGeom prst="ellipse">
+            <a:avLst/>
+          </a:prstGeom>
+          <a:solidFill>
+            <a:srgbClr val="C25E28"/>
+          </a:solidFill>
+          <a:ln w="12700">
+            <a:solidFill>
+              <a:srgbClr val="C25E28"/>
+            </a:solidFill>
+            <a:prstDash val="solid"/>
+          </a:ln>
+        </p:spPr>
+      </p:sp>
+      <p:sp>
+        <p:nvSpPr>
+          <p:cNvPr id="8" name="Text 6"/>
+          <p:cNvSpPr/>
+          <p:nvPr/>
+        </p:nvSpPr>
+        <p:spPr>
+          <a:xfrm>
+            <a:off x="1371600" y="3337560"/>
+            <a:ext cx="4160520" cy="384048"/>
+          </a:xfrm>
+          <a:prstGeom prst="rect">
+            <a:avLst/>
+          </a:prstGeom>
+          <a:noFill/>
+          <a:ln/>
+        </p:spPr>
+        <p:txBody>
+          <a:bodyPr wrap="square" lIns="0" tIns="0" rIns="0" bIns="0" rtlCol="0" anchor="ctr"/>
+          <a:lstStyle/>
+          <a:p>
+            <a:pPr indent="0" marL="0">
+              <a:buNone/>
+            </a:pPr>
+            <a:r>
+              <a:rPr lang="en-US" sz="1350" dirty="0">
+                <a:solidFill>
+                  <a:srgbClr val="3E4C57"/>
+                </a:solidFill>
+                <a:latin typeface="Calibri" pitchFamily="34" charset="0"/>
+                <a:ea typeface="Calibri" pitchFamily="34" charset="-122"/>
+                <a:cs typeface="Calibri" pitchFamily="34" charset="-120"/>
+              </a:rPr>
+              <a:t>Witnesses are the peers we already transmit to.</a:t>
+            </a:r>
+            <a:endParaRPr lang="en-US" sz="1350" dirty="0"/>
+          </a:p>
+        </p:txBody>
+      </p:sp>
+      <p:sp>
+        <p:nvSpPr>
+          <p:cNvPr id="9" name="Shape 7"/>
+          <p:cNvSpPr/>
+          <p:nvPr/>
+        </p:nvSpPr>
+        <p:spPr>
+          <a:xfrm>
+            <a:off x="1051560" y="3840480"/>
+            <a:ext cx="118872" cy="118872"/>
+          </a:xfrm>
+          <a:prstGeom prst="ellipse">
+            <a:avLst/>
+          </a:prstGeom>
+          <a:solidFill>
+            <a:srgbClr val="C25E28"/>
+          </a:solidFill>
+          <a:ln w="12700">
+            <a:solidFill>
+              <a:srgbClr val="C25E28"/>
+            </a:solidFill>
+            <a:prstDash val="solid"/>
+          </a:ln>
+        </p:spPr>
+      </p:sp>
+      <p:sp>
+        <p:nvSpPr>
+          <p:cNvPr id="10" name="Text 8"/>
+          <p:cNvSpPr/>
+          <p:nvPr/>
+        </p:nvSpPr>
+        <p:spPr>
+          <a:xfrm>
+            <a:off x="1371600" y="3721608"/>
+            <a:ext cx="4160520" cy="384048"/>
+          </a:xfrm>
+          <a:prstGeom prst="rect">
+            <a:avLst/>
+          </a:prstGeom>
+          <a:noFill/>
+          <a:ln/>
+        </p:spPr>
+        <p:txBody>
+          <a:bodyPr wrap="square" lIns="0" tIns="0" rIns="0" bIns="0" rtlCol="0" anchor="ctr"/>
+          <a:lstStyle/>
+          <a:p>
+            <a:pPr indent="0" marL="0">
+              <a:buNone/>
+            </a:pPr>
+            <a:r>
+              <a:rPr lang="en-US" sz="1350" dirty="0">
+                <a:solidFill>
+                  <a:srgbClr val="3E4C57"/>
+                </a:solidFill>
+                <a:latin typeface="Calibri" pitchFamily="34" charset="0"/>
+                <a:ea typeface="Calibri" pitchFamily="34" charset="-122"/>
+                <a:cs typeface="Calibri" pitchFamily="34" charset="-120"/>
+              </a:rPr>
+              <a:t>It measures our own mapping, not the NAT rule.</a:t>
+            </a:r>
+            <a:endParaRPr lang="en-US" sz="1350" dirty="0"/>
+          </a:p>
+        </p:txBody>
+      </p:sp>
+      <p:sp>
+        <p:nvSpPr>
+          <p:cNvPr id="11" name="Shape 9"/>
+          <p:cNvSpPr/>
+          <p:nvPr/>
+        </p:nvSpPr>
+        <p:spPr>
+          <a:xfrm>
+            <a:off x="1051560" y="4224528"/>
+            <a:ext cx="118872" cy="118872"/>
+          </a:xfrm>
+          <a:prstGeom prst="ellipse">
+            <a:avLst/>
+          </a:prstGeom>
+          <a:solidFill>
+            <a:srgbClr val="C25E28"/>
+          </a:solidFill>
+          <a:ln w="12700">
+            <a:solidFill>
+              <a:srgbClr val="C25E28"/>
+            </a:solidFill>
+            <a:prstDash val="solid"/>
+          </a:ln>
+        </p:spPr>
+      </p:sp>
+      <p:sp>
+        <p:nvSpPr>
+          <p:cNvPr id="12" name="Text 10"/>
+          <p:cNvSpPr/>
+          <p:nvPr/>
+        </p:nvSpPr>
+        <p:spPr>
+          <a:xfrm>
+            <a:off x="1371600" y="4105656"/>
+            <a:ext cx="4160520" cy="384048"/>
+          </a:xfrm>
+          <a:prstGeom prst="rect">
+            <a:avLst/>
+          </a:prstGeom>
+          <a:noFill/>
+          <a:ln/>
+        </p:spPr>
+        <p:txBody>
+          <a:bodyPr wrap="square" lIns="0" tIns="0" rIns="0" bIns="0" rtlCol="0" anchor="ctr"/>
+          <a:lstStyle/>
+          <a:p>
+            <a:pPr indent="0" marL="0">
+              <a:buNone/>
+            </a:pPr>
+            <a:r>
+              <a:rPr lang="en-US" sz="1350" dirty="0">
+                <a:solidFill>
+                  <a:srgbClr val="3E4C57"/>
+                </a:solidFill>
+                <a:latin typeface="Calibri" pitchFamily="34" charset="0"/>
+                <a:ea typeface="Calibri" pitchFamily="34" charset="-122"/>
+                <a:cs typeface="Calibri" pitchFamily="34" charset="-120"/>
+              </a:rPr>
+              <a:t>Guard: a per-test send history discards contacted sources.</a:t>
+            </a:r>
+            <a:endParaRPr lang="en-US" sz="1350" dirty="0"/>
+          </a:p>
+        </p:txBody>
+      </p:sp>
+      <p:sp>
+        <p:nvSpPr>
+          <p:cNvPr id="13" name="Shape 11"/>
+          <p:cNvSpPr/>
+          <p:nvPr/>
+        </p:nvSpPr>
+        <p:spPr>
+          <a:xfrm>
+            <a:off x="6263640" y="2103120"/>
+            <a:ext cx="5212080" cy="2651760"/>
           </a:xfrm>
           <a:prstGeom prst="roundRect">
             <a:avLst>
-              <a:gd name="adj" fmla="val 4000"/>
+              <a:gd name="adj" fmla="val 2069"/>
             </a:avLst>
           </a:prstGeom>
           <a:solidFill>
@@ -5662,236 +5935,14 @@
       </p:sp>
       <p:sp>
         <p:nvSpPr>
-          <p:cNvPr id="7" name="Text 5"/>
-          <p:cNvSpPr/>
-          <p:nvPr/>
-        </p:nvSpPr>
-        <p:spPr>
-          <a:xfrm>
-            <a:off x="3566160" y="2194560"/>
-            <a:ext cx="2286000" cy="1371600"/>
-          </a:xfrm>
-          <a:prstGeom prst="rect">
-            <a:avLst/>
-          </a:prstGeom>
-          <a:noFill/>
-          <a:ln/>
-        </p:spPr>
-        <p:txBody>
-          <a:bodyPr wrap="square" lIns="0" tIns="0" rIns="0" bIns="0" rtlCol="0" anchor="ctr"/>
-          <a:lstStyle/>
-          <a:p>
-            <a:pPr algn="ctr" indent="0" marL="0">
-              <a:buNone/>
-            </a:pPr>
-            <a:r>
-              <a:rPr lang="en-US" sz="1700" b="1" dirty="0">
-                <a:solidFill>
-                  <a:srgbClr val="0A5A62"/>
-                </a:solidFill>
-                <a:latin typeface="Cambria" pitchFamily="34" charset="0"/>
-                <a:ea typeface="Cambria" pitchFamily="34" charset="-122"/>
-                <a:cs typeface="Cambria" pitchFamily="34" charset="-120"/>
-              </a:rPr>
-              <a:t>Filtering</a:t>
-            </a:r>
-            <a:endParaRPr lang="en-US" sz="1700" dirty="0"/>
-          </a:p>
-          <a:p>
-            <a:pPr algn="ctr" indent="0" marL="0">
-              <a:buNone/>
-            </a:pPr>
-            <a:r>
-              <a:rPr lang="en-US" sz="1700" b="1" dirty="0">
-                <a:solidFill>
-                  <a:srgbClr val="0A5A62"/>
-                </a:solidFill>
-                <a:latin typeface="Cambria" pitchFamily="34" charset="0"/>
-                <a:ea typeface="Cambria" pitchFamily="34" charset="-122"/>
-                <a:cs typeface="Cambria" pitchFamily="34" charset="-120"/>
-              </a:rPr>
-              <a:t>behavior</a:t>
-            </a:r>
-            <a:endParaRPr lang="en-US" sz="1700" dirty="0"/>
-          </a:p>
-        </p:txBody>
-      </p:sp>
-      <p:sp>
-        <p:nvSpPr>
-          <p:cNvPr id="8" name="Shape 6"/>
-          <p:cNvSpPr/>
-          <p:nvPr/>
-        </p:nvSpPr>
-        <p:spPr>
-          <a:xfrm>
-            <a:off x="6263640" y="2194560"/>
-            <a:ext cx="2468880" cy="1371600"/>
-          </a:xfrm>
-          <a:prstGeom prst="roundRect">
-            <a:avLst>
-              <a:gd name="adj" fmla="val 4000"/>
-            </a:avLst>
-          </a:prstGeom>
-          <a:solidFill>
-            <a:srgbClr val="EEF3F4"/>
-          </a:solidFill>
-          <a:ln w="6350">
-            <a:solidFill>
-              <a:srgbClr val="EEF3F4"/>
-            </a:solidFill>
-            <a:prstDash val="solid"/>
-          </a:ln>
-        </p:spPr>
-      </p:sp>
-      <p:sp>
-        <p:nvSpPr>
-          <p:cNvPr id="9" name="Text 7"/>
-          <p:cNvSpPr/>
-          <p:nvPr/>
-        </p:nvSpPr>
-        <p:spPr>
-          <a:xfrm>
-            <a:off x="6355080" y="2194560"/>
-            <a:ext cx="2286000" cy="1371600"/>
-          </a:xfrm>
-          <a:prstGeom prst="rect">
-            <a:avLst/>
-          </a:prstGeom>
-          <a:noFill/>
-          <a:ln/>
-        </p:spPr>
-        <p:txBody>
-          <a:bodyPr wrap="square" lIns="0" tIns="0" rIns="0" bIns="0" rtlCol="0" anchor="ctr"/>
-          <a:lstStyle/>
-          <a:p>
-            <a:pPr algn="ctr" indent="0" marL="0">
-              <a:buNone/>
-            </a:pPr>
-            <a:r>
-              <a:rPr lang="en-US" sz="1700" b="1" dirty="0">
-                <a:solidFill>
-                  <a:srgbClr val="0A5A62"/>
-                </a:solidFill>
-                <a:latin typeface="Cambria" pitchFamily="34" charset="0"/>
-                <a:ea typeface="Cambria" pitchFamily="34" charset="-122"/>
-                <a:cs typeface="Cambria" pitchFamily="34" charset="-120"/>
-              </a:rPr>
-              <a:t>Port</a:t>
-            </a:r>
-            <a:endParaRPr lang="en-US" sz="1700" dirty="0"/>
-          </a:p>
-          <a:p>
-            <a:pPr algn="ctr" indent="0" marL="0">
-              <a:buNone/>
-            </a:pPr>
-            <a:r>
-              <a:rPr lang="en-US" sz="1700" b="1" dirty="0">
-                <a:solidFill>
-                  <a:srgbClr val="0A5A62"/>
-                </a:solidFill>
-                <a:latin typeface="Cambria" pitchFamily="34" charset="0"/>
-                <a:ea typeface="Cambria" pitchFamily="34" charset="-122"/>
-                <a:cs typeface="Cambria" pitchFamily="34" charset="-120"/>
-              </a:rPr>
-              <a:t>preservation</a:t>
-            </a:r>
-            <a:endParaRPr lang="en-US" sz="1700" dirty="0"/>
-          </a:p>
-        </p:txBody>
-      </p:sp>
-      <p:sp>
-        <p:nvSpPr>
-          <p:cNvPr id="10" name="Shape 8"/>
-          <p:cNvSpPr/>
-          <p:nvPr/>
-        </p:nvSpPr>
-        <p:spPr>
-          <a:xfrm>
-            <a:off x="9052560" y="2194560"/>
-            <a:ext cx="2468880" cy="1371600"/>
-          </a:xfrm>
-          <a:prstGeom prst="roundRect">
-            <a:avLst>
-              <a:gd name="adj" fmla="val 4000"/>
-            </a:avLst>
-          </a:prstGeom>
-          <a:solidFill>
-            <a:srgbClr val="EEF3F4"/>
-          </a:solidFill>
-          <a:ln w="6350">
-            <a:solidFill>
-              <a:srgbClr val="EEF3F4"/>
-            </a:solidFill>
-            <a:prstDash val="solid"/>
-          </a:ln>
-        </p:spPr>
-      </p:sp>
-      <p:sp>
-        <p:nvSpPr>
-          <p:cNvPr id="11" name="Text 9"/>
-          <p:cNvSpPr/>
-          <p:nvPr/>
-        </p:nvSpPr>
-        <p:spPr>
-          <a:xfrm>
-            <a:off x="9144000" y="2194560"/>
-            <a:ext cx="2286000" cy="1371600"/>
-          </a:xfrm>
-          <a:prstGeom prst="rect">
-            <a:avLst/>
-          </a:prstGeom>
-          <a:noFill/>
-          <a:ln/>
-        </p:spPr>
-        <p:txBody>
-          <a:bodyPr wrap="square" lIns="0" tIns="0" rIns="0" bIns="0" rtlCol="0" anchor="ctr"/>
-          <a:lstStyle/>
-          <a:p>
-            <a:pPr algn="ctr" indent="0" marL="0">
-              <a:buNone/>
-            </a:pPr>
-            <a:r>
-              <a:rPr lang="en-US" sz="1700" b="1" dirty="0">
-                <a:solidFill>
-                  <a:srgbClr val="0A5A62"/>
-                </a:solidFill>
-                <a:latin typeface="Cambria" pitchFamily="34" charset="0"/>
-                <a:ea typeface="Cambria" pitchFamily="34" charset="-122"/>
-                <a:cs typeface="Cambria" pitchFamily="34" charset="-120"/>
-              </a:rPr>
-              <a:t>Mapping</a:t>
-            </a:r>
-            <a:endParaRPr lang="en-US" sz="1700" dirty="0"/>
-          </a:p>
-          <a:p>
-            <a:pPr algn="ctr" indent="0" marL="0">
-              <a:buNone/>
-            </a:pPr>
-            <a:r>
-              <a:rPr lang="en-US" sz="1700" b="1" dirty="0">
-                <a:solidFill>
-                  <a:srgbClr val="0A5A62"/>
-                </a:solidFill>
-                <a:latin typeface="Cambria" pitchFamily="34" charset="0"/>
-                <a:ea typeface="Cambria" pitchFamily="34" charset="-122"/>
-                <a:cs typeface="Cambria" pitchFamily="34" charset="-120"/>
-              </a:rPr>
-              <a:t>lifetime</a:t>
-            </a:r>
-            <a:endParaRPr lang="en-US" sz="1700" dirty="0"/>
-          </a:p>
-        </p:txBody>
-      </p:sp>
-      <p:sp>
-        <p:nvSpPr>
-          <p:cNvPr id="12" name="Shape 10"/>
-          <p:cNvSpPr/>
-          <p:nvPr/>
-        </p:nvSpPr>
-        <p:spPr>
-          <a:xfrm>
-            <a:off x="685800" y="4142232"/>
-            <a:ext cx="118872" cy="118872"/>
+          <p:cNvPr id="14" name="Shape 12"/>
+          <p:cNvSpPr/>
+          <p:nvPr/>
+        </p:nvSpPr>
+        <p:spPr>
+          <a:xfrm>
+            <a:off x="6629400" y="2377440"/>
+            <a:ext cx="365760" cy="365760"/>
           </a:xfrm>
           <a:prstGeom prst="ellipse">
             <a:avLst/>
@@ -5909,52 +5960,52 @@
       </p:sp>
       <p:sp>
         <p:nvSpPr>
-          <p:cNvPr id="13" name="Text 11"/>
-          <p:cNvSpPr/>
-          <p:nvPr/>
-        </p:nvSpPr>
-        <p:spPr>
-          <a:xfrm>
-            <a:off x="1005840" y="4023360"/>
-            <a:ext cx="10469880" cy="384048"/>
-          </a:xfrm>
-          <a:prstGeom prst="rect">
-            <a:avLst/>
-          </a:prstGeom>
-          <a:noFill/>
-          <a:ln/>
-        </p:spPr>
-        <p:txBody>
-          <a:bodyPr wrap="square" lIns="0" tIns="0" rIns="0" bIns="0" rtlCol="0" anchor="ctr"/>
-          <a:lstStyle/>
-          <a:p>
-            <a:pPr indent="0" marL="0">
-              <a:buNone/>
-            </a:pPr>
-            <a:r>
-              <a:rPr lang="en-US" sz="1650" dirty="0">
-                <a:solidFill>
-                  <a:srgbClr val="3E4C57"/>
-                </a:solidFill>
-                <a:latin typeface="Calibri" pitchFamily="34" charset="0"/>
-                <a:ea typeface="Calibri" pitchFamily="34" charset="-122"/>
-                <a:cs typeface="Calibri" pitchFamily="34" charset="-120"/>
-              </a:rPr>
-              <a:t>A tuple, not a NAT type; a single label is derived, never measured.</a:t>
-            </a:r>
-            <a:endParaRPr lang="en-US" sz="1650" dirty="0"/>
-          </a:p>
-        </p:txBody>
-      </p:sp>
-      <p:sp>
-        <p:nvSpPr>
-          <p:cNvPr id="14" name="Shape 12"/>
-          <p:cNvSpPr/>
-          <p:nvPr/>
-        </p:nvSpPr>
-        <p:spPr>
-          <a:xfrm>
-            <a:off x="685800" y="4581144"/>
+          <p:cNvPr id="15" name="Text 13"/>
+          <p:cNvSpPr/>
+          <p:nvPr/>
+        </p:nvSpPr>
+        <p:spPr>
+          <a:xfrm>
+            <a:off x="6629400" y="2880360"/>
+            <a:ext cx="4480560" cy="365760"/>
+          </a:xfrm>
+          <a:prstGeom prst="rect">
+            <a:avLst/>
+          </a:prstGeom>
+          <a:noFill/>
+          <a:ln/>
+        </p:spPr>
+        <p:txBody>
+          <a:bodyPr wrap="square" lIns="0" tIns="0" rIns="0" bIns="0" rtlCol="0" anchor="ctr"/>
+          <a:lstStyle/>
+          <a:p>
+            <a:pPr indent="0" marL="0">
+              <a:buNone/>
+            </a:pPr>
+            <a:r>
+              <a:rPr lang="en-US" sz="2000" b="1" dirty="0">
+                <a:solidFill>
+                  <a:srgbClr val="16202A"/>
+                </a:solidFill>
+                <a:latin typeface="Cambria" pitchFamily="34" charset="0"/>
+                <a:ea typeface="Cambria" pitchFamily="34" charset="-122"/>
+                <a:cs typeface="Cambria" pitchFamily="34" charset="-120"/>
+              </a:rPr>
+              <a:t>Dishonest witnesses</a:t>
+            </a:r>
+            <a:endParaRPr lang="en-US" sz="2000" dirty="0"/>
+          </a:p>
+        </p:txBody>
+      </p:sp>
+      <p:sp>
+        <p:nvSpPr>
+          <p:cNvPr id="16" name="Shape 14"/>
+          <p:cNvSpPr/>
+          <p:nvPr/>
+        </p:nvSpPr>
+        <p:spPr>
+          <a:xfrm>
+            <a:off x="6629400" y="3456432"/>
             <a:ext cx="118872" cy="118872"/>
           </a:xfrm>
           <a:prstGeom prst="ellipse">
@@ -5973,30 +6024,30 @@
       </p:sp>
       <p:sp>
         <p:nvSpPr>
-          <p:cNvPr id="15" name="Text 13"/>
-          <p:cNvSpPr/>
-          <p:nvPr/>
-        </p:nvSpPr>
-        <p:spPr>
-          <a:xfrm>
-            <a:off x="1005840" y="4462272"/>
-            <a:ext cx="10469880" cy="384048"/>
-          </a:xfrm>
-          <a:prstGeom prst="rect">
-            <a:avLst/>
-          </a:prstGeom>
-          <a:noFill/>
-          <a:ln/>
-        </p:spPr>
-        <p:txBody>
-          <a:bodyPr wrap="square" lIns="0" tIns="0" rIns="0" bIns="0" rtlCol="0" anchor="ctr"/>
-          <a:lstStyle/>
-          <a:p>
-            <a:pPr indent="0" marL="0">
-              <a:buNone/>
-            </a:pPr>
-            <a:r>
-              <a:rPr lang="en-US" sz="1650" dirty="0">
+          <p:cNvPr id="17" name="Text 15"/>
+          <p:cNvSpPr/>
+          <p:nvPr/>
+        </p:nvSpPr>
+        <p:spPr>
+          <a:xfrm>
+            <a:off x="6949440" y="3337560"/>
+            <a:ext cx="4160520" cy="384048"/>
+          </a:xfrm>
+          <a:prstGeom prst="rect">
+            <a:avLst/>
+          </a:prstGeom>
+          <a:noFill/>
+          <a:ln/>
+        </p:spPr>
+        <p:txBody>
+          <a:bodyPr wrap="square" lIns="0" tIns="0" rIns="0" bIns="0" rtlCol="0" anchor="ctr"/>
+          <a:lstStyle/>
+          <a:p>
+            <a:pPr indent="0" marL="0">
+              <a:buNone/>
+            </a:pPr>
+            <a:r>
+              <a:rPr lang="en-US" sz="1350" dirty="0">
                 <a:solidFill>
                   <a:srgbClr val="3E4C57"/>
                 </a:solidFill>
@@ -6004,21 +6055,21 @@
                 <a:ea typeface="Calibri" pitchFamily="34" charset="-122"/>
                 <a:cs typeface="Calibri" pitchFamily="34" charset="-120"/>
               </a:rPr>
-              <a:t>Reported per address family and per translation path.</a:t>
-            </a:r>
-            <a:endParaRPr lang="en-US" sz="1650" dirty="0"/>
-          </a:p>
-        </p:txBody>
-      </p:sp>
-      <p:sp>
-        <p:nvSpPr>
-          <p:cNvPr id="16" name="Shape 14"/>
-          <p:cNvSpPr/>
-          <p:nvPr/>
-        </p:nvSpPr>
-        <p:spPr>
-          <a:xfrm>
-            <a:off x="685800" y="5020056"/>
+              <a:t>A nonce cannot be forged, but a failure can be fabricated.</a:t>
+            </a:r>
+            <a:endParaRPr lang="en-US" sz="1350" dirty="0"/>
+          </a:p>
+        </p:txBody>
+      </p:sp>
+      <p:sp>
+        <p:nvSpPr>
+          <p:cNvPr id="18" name="Shape 16"/>
+          <p:cNvSpPr/>
+          <p:nvPr/>
+        </p:nvSpPr>
+        <p:spPr>
+          <a:xfrm>
+            <a:off x="6629400" y="3840480"/>
             <a:ext cx="118872" cy="118872"/>
           </a:xfrm>
           <a:prstGeom prst="ellipse">
@@ -6037,30 +6088,30 @@
       </p:sp>
       <p:sp>
         <p:nvSpPr>
-          <p:cNvPr id="17" name="Text 15"/>
-          <p:cNvSpPr/>
-          <p:nvPr/>
-        </p:nvSpPr>
-        <p:spPr>
-          <a:xfrm>
-            <a:off x="1005840" y="4901184"/>
-            <a:ext cx="10469880" cy="384048"/>
-          </a:xfrm>
-          <a:prstGeom prst="rect">
-            <a:avLst/>
-          </a:prstGeom>
-          <a:noFill/>
-          <a:ln/>
-        </p:spPr>
-        <p:txBody>
-          <a:bodyPr wrap="square" lIns="0" tIns="0" rIns="0" bIns="0" rtlCol="0" anchor="ctr"/>
-          <a:lstStyle/>
-          <a:p>
-            <a:pPr indent="0" marL="0">
-              <a:buNone/>
-            </a:pPr>
-            <a:r>
-              <a:rPr lang="en-US" sz="1650" dirty="0">
+          <p:cNvPr id="19" name="Text 17"/>
+          <p:cNvSpPr/>
+          <p:nvPr/>
+        </p:nvSpPr>
+        <p:spPr>
+          <a:xfrm>
+            <a:off x="6949440" y="3721608"/>
+            <a:ext cx="4160520" cy="384048"/>
+          </a:xfrm>
+          <a:prstGeom prst="rect">
+            <a:avLst/>
+          </a:prstGeom>
+          <a:noFill/>
+          <a:ln/>
+        </p:spPr>
+        <p:txBody>
+          <a:bodyPr wrap="square" lIns="0" tIns="0" rIns="0" bIns="0" rtlCol="0" anchor="ctr"/>
+          <a:lstStyle/>
+          <a:p>
+            <a:pPr indent="0" marL="0">
+              <a:buNone/>
+            </a:pPr>
+            <a:r>
+              <a:rPr lang="en-US" sz="1350" dirty="0">
                 <a:solidFill>
                   <a:srgbClr val="3E4C57"/>
                 </a:solidFill>
@@ -6068,21 +6119,21 @@
                 <a:ea typeface="Calibri" pitchFamily="34" charset="-122"/>
                 <a:cs typeface="Calibri" pitchFamily="34" charset="-120"/>
               </a:rPr>
-              <a:t>autoNAT reports reachability only, so it cannot be the ground truth.</a:t>
-            </a:r>
-            <a:endParaRPr lang="en-US" sz="1650" dirty="0"/>
-          </a:p>
-        </p:txBody>
-      </p:sp>
-      <p:sp>
-        <p:nvSpPr>
-          <p:cNvPr id="18" name="Shape 16"/>
-          <p:cNvSpPr/>
-          <p:nvPr/>
-        </p:nvSpPr>
-        <p:spPr>
-          <a:xfrm>
-            <a:off x="685800" y="5458968"/>
+              <a:t>One verified success proves reachability.</a:t>
+            </a:r>
+            <a:endParaRPr lang="en-US" sz="1350" dirty="0"/>
+          </a:p>
+        </p:txBody>
+      </p:sp>
+      <p:sp>
+        <p:nvSpPr>
+          <p:cNvPr id="20" name="Shape 18"/>
+          <p:cNvSpPr/>
+          <p:nvPr/>
+        </p:nvSpPr>
+        <p:spPr>
+          <a:xfrm>
+            <a:off x="6629400" y="4224528"/>
             <a:ext cx="118872" cy="118872"/>
           </a:xfrm>
           <a:prstGeom prst="ellipse">
@@ -6101,30 +6152,30 @@
       </p:sp>
       <p:sp>
         <p:nvSpPr>
-          <p:cNvPr id="19" name="Text 17"/>
-          <p:cNvSpPr/>
-          <p:nvPr/>
-        </p:nvSpPr>
-        <p:spPr>
-          <a:xfrm>
-            <a:off x="1005840" y="5340096"/>
-            <a:ext cx="10469880" cy="384048"/>
-          </a:xfrm>
-          <a:prstGeom prst="rect">
-            <a:avLst/>
-          </a:prstGeom>
-          <a:noFill/>
-          <a:ln/>
-        </p:spPr>
-        <p:txBody>
-          <a:bodyPr wrap="square" lIns="0" tIns="0" rIns="0" bIns="0" rtlCol="0" anchor="ctr"/>
-          <a:lstStyle/>
-          <a:p>
-            <a:pPr indent="0" marL="0">
-              <a:buNone/>
-            </a:pPr>
-            <a:r>
-              <a:rPr lang="en-US" sz="1650" dirty="0">
+          <p:cNvPr id="21" name="Text 19"/>
+          <p:cNvSpPr/>
+          <p:nvPr/>
+        </p:nvSpPr>
+        <p:spPr>
+          <a:xfrm>
+            <a:off x="6949440" y="4105656"/>
+            <a:ext cx="4160520" cy="384048"/>
+          </a:xfrm>
+          <a:prstGeom prst="rect">
+            <a:avLst/>
+          </a:prstGeom>
+          <a:noFill/>
+          <a:ln/>
+        </p:spPr>
+        <p:txBody>
+          <a:bodyPr wrap="square" lIns="0" tIns="0" rIns="0" bIns="0" rtlCol="0" anchor="ctr"/>
+          <a:lstStyle/>
+          <a:p>
+            <a:pPr indent="0" marL="0">
+              <a:buNone/>
+            </a:pPr>
+            <a:r>
+              <a:rPr lang="en-US" sz="1350" dirty="0">
                 <a:solidFill>
                   <a:srgbClr val="3E4C57"/>
                 </a:solidFill>
@@ -6132,9 +6183,48 @@
                 <a:ea typeface="Calibri" pitchFamily="34" charset="-122"/>
                 <a:cs typeface="Calibri" pitchFamily="34" charset="-120"/>
               </a:rPr>
-              <a:t>Classification is validated against an RFC 5780 server we operate.</a:t>
-            </a:r>
-            <a:endParaRPr lang="en-US" sz="1650" dirty="0"/>
+              <a:t>Unreachability needs k independent failures.</a:t>
+            </a:r>
+            <a:endParaRPr lang="en-US" sz="1350" dirty="0"/>
+          </a:p>
+        </p:txBody>
+      </p:sp>
+      <p:sp>
+        <p:nvSpPr>
+          <p:cNvPr id="22" name="Text 20"/>
+          <p:cNvSpPr/>
+          <p:nvPr/>
+        </p:nvSpPr>
+        <p:spPr>
+          <a:xfrm>
+            <a:off x="685800" y="5120640"/>
+            <a:ext cx="10789920" cy="365760"/>
+          </a:xfrm>
+          <a:prstGeom prst="rect">
+            <a:avLst/>
+          </a:prstGeom>
+          <a:noFill/>
+          <a:ln/>
+        </p:spPr>
+        <p:txBody>
+          <a:bodyPr wrap="square" lIns="0" tIns="0" rIns="0" bIns="0" rtlCol="0" anchor="ctr"/>
+          <a:lstStyle/>
+          <a:p>
+            <a:pPr indent="0" marL="0">
+              <a:buNone/>
+            </a:pPr>
+            <a:r>
+              <a:rPr lang="en-US" sz="1500" i="1" dirty="0">
+                <a:solidFill>
+                  <a:srgbClr val="0A5A62"/>
+                </a:solidFill>
+                <a:latin typeface="Calibri" pitchFamily="34" charset="0"/>
+                <a:ea typeface="Calibri" pitchFamily="34" charset="-122"/>
+                <a:cs typeface="Calibri" pitchFamily="34" charset="-120"/>
+              </a:rPr>
+              <a:t>Both are studied on the bench, where we operate every witness and know who lied.</a:t>
+            </a:r>
+            <a:endParaRPr lang="en-US" sz="1500" dirty="0"/>
           </a:p>
         </p:txBody>
       </p:sp>
@@ -6762,8 +6852,8 @@
         </p:nvSpPr>
         <p:spPr>
           <a:xfrm>
-            <a:off x="685800" y="5760720"/>
-            <a:ext cx="10789920" cy="365760"/>
+            <a:off x="685800" y="5623560"/>
+            <a:ext cx="10789920" cy="320040"/>
           </a:xfrm>
           <a:prstGeom prst="rect">
             <a:avLst/>
@@ -6788,6 +6878,45 @@
                 <a:cs typeface="Calibri" pitchFamily="34" charset="-120"/>
               </a:rPr>
               <a:t>Address-dependent mapping is built deliberately; no netfilter flag produces it.</a:t>
+            </a:r>
+            <a:endParaRPr lang="en-US" sz="1500" dirty="0"/>
+          </a:p>
+        </p:txBody>
+      </p:sp>
+      <p:sp>
+        <p:nvSpPr>
+          <p:cNvPr id="20" name="Text 18"/>
+          <p:cNvSpPr/>
+          <p:nvPr/>
+        </p:nvSpPr>
+        <p:spPr>
+          <a:xfrm>
+            <a:off x="685800" y="5989320"/>
+            <a:ext cx="10789920" cy="320040"/>
+          </a:xfrm>
+          <a:prstGeom prst="rect">
+            <a:avLst/>
+          </a:prstGeom>
+          <a:noFill/>
+          <a:ln/>
+        </p:spPr>
+        <p:txBody>
+          <a:bodyPr wrap="square" lIns="0" tIns="0" rIns="0" bIns="0" rtlCol="0" anchor="ctr"/>
+          <a:lstStyle/>
+          <a:p>
+            <a:pPr indent="0" marL="0">
+              <a:buNone/>
+            </a:pPr>
+            <a:r>
+              <a:rPr lang="en-US" sz="1500" i="1" dirty="0">
+                <a:solidFill>
+                  <a:srgbClr val="0A5A62"/>
+                </a:solidFill>
+                <a:latin typeface="Calibri" pitchFamily="34" charset="0"/>
+                <a:ea typeface="Calibri" pitchFamily="34" charset="-122"/>
+                <a:cs typeface="Calibri" pitchFamily="34" charset="-120"/>
+              </a:rPr>
+              <a:t>autoNAT reports reachability only, so classification is validated against the RFC 5780 server.</a:t>
             </a:r>
             <a:endParaRPr lang="en-US" sz="1500" dirty="0"/>
           </a:p>

</xml_diff>